<commit_message>
Cerrar inscripciones a cohorte en curso, apuntar a lista de espera
</commit_message>
<xml_diff>
--- a/A1_Nivel_1/03_Saludos/Sesion_03_Saludos.pptx
+++ b/A1_Nivel_1/03_Saludos/Sesion_03_Saludos.pptx
@@ -4,6 +4,9 @@
   <p:sldMasterIdLst>
     <p:sldMasterId id="2147483648" r:id="rId1"/>
   </p:sldMasterIdLst>
+  <p:notesMasterIdLst>
+    <p:notesMasterId r:id="rId19"/>
+  </p:notesMasterIdLst>
   <p:sldIdLst>
     <p:sldId id="256" r:id="rId2"/>
     <p:sldId id="257" r:id="rId3"/>
@@ -23,9 +26,6 @@
     <p:sldId id="271" r:id="rId17"/>
     <p:sldId id="272" r:id="rId18"/>
   </p:sldIdLst>
-  <p:notesMasterIdLst>
-    <p:notesMasterId r:id="rId19"/>
-  </p:notesMasterIdLst>
   <p:sldSz cx="12192000" cy="6858000"/>
   <p:notesSz cx="6858000" cy="12192000"/>
   <p:defaultTextStyle>
@@ -120,6 +120,11 @@
       </a:defRPr>
     </a:lvl9pPr>
   </p:defaultTextStyle>
+  <p:extLst>
+    <p:ext uri="{EFAFB233-063F-42B5-8137-9DF3F51BA10A}">
+      <p15:sldGuideLst xmlns:p15="http://schemas.microsoft.com/office/powerpoint/2012/main"/>
+    </p:ext>
+  </p:extLst>
 </p:presentation>
 </file>
 
@@ -145,234 +150,10 @@
           <a:chExt cx="0" cy="0"/>
         </a:xfrm>
       </p:grpSpPr>
-      <p:sp>
-        <p:nvSpPr>
-          <p:cNvPr id="2" name="Header Placeholder 1"/>
-          <p:cNvSpPr>
-            <a:spLocks noGrp="1"/>
-          </p:cNvSpPr>
-          <p:nvPr>
-            <p:ph type="hdr" sz="quarter"/>
-          </p:nvPr>
-        </p:nvSpPr>
-        <p:spPr>
-          <a:xfrm>
-            <a:off x="0" y="0"/>
-            <a:ext cx="2971800" cy="458788"/>
-          </a:xfrm>
-          <a:prstGeom prst="rect">
-            <a:avLst/>
-          </a:prstGeom>
-        </p:spPr>
-        <p:txBody>
-          <a:bodyPr vert="horz" lIns="91440" tIns="45720" rIns="91440" bIns="45720" rtlCol="0"/>
-          <a:lstStyle>
-            <a:lvl1pPr algn="l">
-              <a:defRPr sz="1200"/>
-            </a:lvl1pPr>
-          </a:lstStyle>
-          <a:p>
-            <a:endParaRPr lang="en-US"/>
-          </a:p>
-        </p:txBody>
-      </p:sp>
-      <p:sp>
-        <p:nvSpPr>
-          <p:cNvPr id="3" name="Date Placeholder 2"/>
-          <p:cNvSpPr>
-            <a:spLocks noGrp="1"/>
-          </p:cNvSpPr>
-          <p:nvPr>
-            <p:ph type="dt" idx="1"/>
-          </p:nvPr>
-        </p:nvSpPr>
-        <p:spPr>
-          <a:xfrm>
-            <a:off x="3884613" y="0"/>
-            <a:ext cx="2971800" cy="458788"/>
-          </a:xfrm>
-          <a:prstGeom prst="rect">
-            <a:avLst/>
-          </a:prstGeom>
-        </p:spPr>
-        <p:txBody>
-          <a:bodyPr vert="horz" lIns="91440" tIns="45720" rIns="91440" bIns="45720" rtlCol="0"/>
-          <a:lstStyle>
-            <a:lvl1pPr algn="r">
-              <a:defRPr sz="1200"/>
-            </a:lvl1pPr>
-          </a:lstStyle>
-          <a:p>
-            <a:fld id="{5282F153-3F37-0F45-9E97-73ACFA13230C}" type="datetimeFigureOut">
-              <a:rPr lang="en-US"/>
-              <a:t>7/23/19</a:t>
-            </a:fld>
-            <a:endParaRPr lang="en-US"/>
-          </a:p>
-        </p:txBody>
-      </p:sp>
-      <p:sp>
-        <p:nvSpPr>
-          <p:cNvPr id="4" name="Slide Image Placeholder 3"/>
-          <p:cNvSpPr>
-            <a:spLocks noGrp="1" noRot="1" noChangeAspect="1"/>
-          </p:cNvSpPr>
-          <p:nvPr>
-            <p:ph type="sldImg" idx="2"/>
-          </p:nvPr>
-        </p:nvSpPr>
-        <p:spPr>
-          <a:xfrm>
-            <a:off x="685800" y="1143000"/>
-            <a:ext cx="5486400" cy="3086100"/>
-          </a:xfrm>
-          <a:prstGeom prst="rect">
-            <a:avLst/>
-          </a:prstGeom>
-          <a:noFill/>
-          <a:ln w="12700">
-            <a:solidFill>
-              <a:prstClr val="black"/>
-            </a:solidFill>
-          </a:ln>
-        </p:spPr>
-        <p:txBody>
-          <a:bodyPr vert="horz" lIns="91440" tIns="45720" rIns="91440" bIns="45720" rtlCol="0" anchor="ctr"/>
-          <a:lstStyle/>
-          <a:p>
-            <a:endParaRPr lang="en-US"/>
-          </a:p>
-        </p:txBody>
-      </p:sp>
-      <p:sp>
-        <p:nvSpPr>
-          <p:cNvPr id="5" name="Notes Placeholder 4"/>
-          <p:cNvSpPr>
-            <a:spLocks noGrp="1"/>
-          </p:cNvSpPr>
-          <p:nvPr>
-            <p:ph type="body" sz="quarter" idx="3"/>
-          </p:nvPr>
-        </p:nvSpPr>
-        <p:spPr>
-          <a:xfrm>
-            <a:off x="685800" y="4400550"/>
-            <a:ext cx="5486400" cy="3600450"/>
-          </a:xfrm>
-          <a:prstGeom prst="rect">
-            <a:avLst/>
-          </a:prstGeom>
-        </p:spPr>
-        <p:txBody>
-          <a:bodyPr vert="horz" lIns="91440" tIns="45720" rIns="91440" bIns="45720" rtlCol="0"/>
-          <a:lstStyle/>
-          <a:p>
-            <a:pPr lvl="0"/>
-            <a:r>
-              <a:rPr lang="en-US"/>
-              <a:t>Click to edit Master text styles</a:t>
-            </a:r>
-          </a:p>
-          <a:p>
-            <a:pPr lvl="1"/>
-            <a:r>
-              <a:rPr lang="en-US"/>
-              <a:t>Second level</a:t>
-            </a:r>
-          </a:p>
-          <a:p>
-            <a:pPr lvl="2"/>
-            <a:r>
-              <a:rPr lang="en-US"/>
-              <a:t>Third level</a:t>
-            </a:r>
-          </a:p>
-          <a:p>
-            <a:pPr lvl="3"/>
-            <a:r>
-              <a:rPr lang="en-US"/>
-              <a:t>Fourth level</a:t>
-            </a:r>
-          </a:p>
-          <a:p>
-            <a:pPr lvl="4"/>
-            <a:r>
-              <a:rPr lang="en-US"/>
-              <a:t>Fifth level</a:t>
-            </a:r>
-          </a:p>
-        </p:txBody>
-      </p:sp>
-      <p:sp>
-        <p:nvSpPr>
-          <p:cNvPr id="6" name="Footer Placeholder 5"/>
-          <p:cNvSpPr>
-            <a:spLocks noGrp="1"/>
-          </p:cNvSpPr>
-          <p:nvPr>
-            <p:ph type="ftr" sz="quarter" idx="4"/>
-          </p:nvPr>
-        </p:nvSpPr>
-        <p:spPr>
-          <a:xfrm>
-            <a:off x="0" y="8685213"/>
-            <a:ext cx="2971800" cy="458787"/>
-          </a:xfrm>
-          <a:prstGeom prst="rect">
-            <a:avLst/>
-          </a:prstGeom>
-        </p:spPr>
-        <p:txBody>
-          <a:bodyPr vert="horz" lIns="91440" tIns="45720" rIns="91440" bIns="45720" rtlCol="0" anchor="b"/>
-          <a:lstStyle>
-            <a:lvl1pPr algn="l">
-              <a:defRPr sz="1200"/>
-            </a:lvl1pPr>
-          </a:lstStyle>
-          <a:p>
-            <a:endParaRPr lang="en-US"/>
-          </a:p>
-        </p:txBody>
-      </p:sp>
-      <p:sp>
-        <p:nvSpPr>
-          <p:cNvPr id="7" name="Slide Number Placeholder 6"/>
-          <p:cNvSpPr>
-            <a:spLocks noGrp="1"/>
-          </p:cNvSpPr>
-          <p:nvPr>
-            <p:ph type="sldNum" sz="quarter" idx="5"/>
-          </p:nvPr>
-        </p:nvSpPr>
-        <p:spPr>
-          <a:xfrm>
-            <a:off x="3884613" y="8685213"/>
-            <a:ext cx="2971800" cy="458787"/>
-          </a:xfrm>
-          <a:prstGeom prst="rect">
-            <a:avLst/>
-          </a:prstGeom>
-        </p:spPr>
-        <p:txBody>
-          <a:bodyPr vert="horz" lIns="91440" tIns="45720" rIns="91440" bIns="45720" rtlCol="0" anchor="b"/>
-          <a:lstStyle>
-            <a:lvl1pPr algn="r">
-              <a:defRPr sz="1200"/>
-            </a:lvl1pPr>
-          </a:lstStyle>
-          <a:p>
-            <a:fld id="{CE5E9CC1-C706-0F49-92D6-E571CC5EEA8F}" type="slidenum">
-              <a:rPr lang="en-US"/>
-              <a:t>‹#›</a:t>
-            </a:fld>
-            <a:endParaRPr lang="en-US"/>
-          </a:p>
-        </p:txBody>
-      </p:sp>
     </p:spTree>
     <p:extLst>
       <p:ext uri="{BB962C8B-B14F-4D97-AF65-F5344CB8AC3E}">
-        <p14:creationId xmlns:p14="http://schemas.microsoft.com/office/powerpoint/2010/main" val="1024086991"/>
+        <p14:creationId xmlns:p14="http://schemas.microsoft.com/office/powerpoint/2010/main" val="886053150"/>
       </p:ext>
     </p:extLst>
   </p:cSld>
@@ -516,10 +297,6 @@
           <a:bodyPr/>
           <a:lstStyle/>
           <a:p>
-            <a:r>
-              <a:rPr lang="en-US" dirty="0"/>
-              <a:t/>
-            </a:r>
             <a:endParaRPr lang="en-US" dirty="0"/>
           </a:p>
         </p:txBody>
@@ -604,10 +381,6 @@
           <a:bodyPr/>
           <a:lstStyle/>
           <a:p>
-            <a:r>
-              <a:rPr lang="en-US" dirty="0"/>
-              <a:t/>
-            </a:r>
             <a:endParaRPr lang="en-US" dirty="0"/>
           </a:p>
         </p:txBody>
@@ -692,10 +465,6 @@
           <a:bodyPr/>
           <a:lstStyle/>
           <a:p>
-            <a:r>
-              <a:rPr lang="en-US" dirty="0"/>
-              <a:t/>
-            </a:r>
             <a:endParaRPr lang="en-US" dirty="0"/>
           </a:p>
         </p:txBody>
@@ -780,10 +549,6 @@
           <a:bodyPr/>
           <a:lstStyle/>
           <a:p>
-            <a:r>
-              <a:rPr lang="en-US" dirty="0"/>
-              <a:t/>
-            </a:r>
             <a:endParaRPr lang="en-US" dirty="0"/>
           </a:p>
         </p:txBody>
@@ -868,10 +633,6 @@
           <a:bodyPr/>
           <a:lstStyle/>
           <a:p>
-            <a:r>
-              <a:rPr lang="en-US" dirty="0"/>
-              <a:t/>
-            </a:r>
             <a:endParaRPr lang="en-US" dirty="0"/>
           </a:p>
         </p:txBody>
@@ -956,10 +717,6 @@
           <a:bodyPr/>
           <a:lstStyle/>
           <a:p>
-            <a:r>
-              <a:rPr lang="en-US" dirty="0"/>
-              <a:t/>
-            </a:r>
             <a:endParaRPr lang="en-US" dirty="0"/>
           </a:p>
         </p:txBody>
@@ -1044,10 +801,6 @@
           <a:bodyPr/>
           <a:lstStyle/>
           <a:p>
-            <a:r>
-              <a:rPr lang="en-US" dirty="0"/>
-              <a:t/>
-            </a:r>
             <a:endParaRPr lang="en-US" dirty="0"/>
           </a:p>
         </p:txBody>
@@ -1132,10 +885,6 @@
           <a:bodyPr/>
           <a:lstStyle/>
           <a:p>
-            <a:r>
-              <a:rPr lang="en-US" dirty="0"/>
-              <a:t/>
-            </a:r>
             <a:endParaRPr lang="en-US" dirty="0"/>
           </a:p>
         </p:txBody>
@@ -1220,10 +969,6 @@
           <a:bodyPr/>
           <a:lstStyle/>
           <a:p>
-            <a:r>
-              <a:rPr lang="en-US" dirty="0"/>
-              <a:t/>
-            </a:r>
             <a:endParaRPr lang="en-US" dirty="0"/>
           </a:p>
         </p:txBody>
@@ -1308,10 +1053,6 @@
           <a:bodyPr/>
           <a:lstStyle/>
           <a:p>
-            <a:r>
-              <a:rPr lang="en-US" dirty="0"/>
-              <a:t/>
-            </a:r>
             <a:endParaRPr lang="en-US" dirty="0"/>
           </a:p>
         </p:txBody>
@@ -1396,10 +1137,6 @@
           <a:bodyPr/>
           <a:lstStyle/>
           <a:p>
-            <a:r>
-              <a:rPr lang="en-US" dirty="0"/>
-              <a:t/>
-            </a:r>
             <a:endParaRPr lang="en-US" dirty="0"/>
           </a:p>
         </p:txBody>
@@ -1484,10 +1221,6 @@
           <a:bodyPr/>
           <a:lstStyle/>
           <a:p>
-            <a:r>
-              <a:rPr lang="en-US" dirty="0"/>
-              <a:t/>
-            </a:r>
             <a:endParaRPr lang="en-US" dirty="0"/>
           </a:p>
         </p:txBody>
@@ -1572,10 +1305,6 @@
           <a:bodyPr/>
           <a:lstStyle/>
           <a:p>
-            <a:r>
-              <a:rPr lang="en-US" dirty="0"/>
-              <a:t/>
-            </a:r>
             <a:endParaRPr lang="en-US" dirty="0"/>
           </a:p>
         </p:txBody>
@@ -1660,10 +1389,6 @@
           <a:bodyPr/>
           <a:lstStyle/>
           <a:p>
-            <a:r>
-              <a:rPr lang="en-US" dirty="0"/>
-              <a:t/>
-            </a:r>
             <a:endParaRPr lang="en-US" dirty="0"/>
           </a:p>
         </p:txBody>
@@ -1748,10 +1473,6 @@
           <a:bodyPr/>
           <a:lstStyle/>
           <a:p>
-            <a:r>
-              <a:rPr lang="en-US" dirty="0"/>
-              <a:t/>
-            </a:r>
             <a:endParaRPr lang="en-US" dirty="0"/>
           </a:p>
         </p:txBody>
@@ -1836,10 +1557,6 @@
           <a:bodyPr/>
           <a:lstStyle/>
           <a:p>
-            <a:r>
-              <a:rPr lang="en-US" dirty="0"/>
-              <a:t/>
-            </a:r>
             <a:endParaRPr lang="en-US" dirty="0"/>
           </a:p>
         </p:txBody>
@@ -1924,10 +1641,6 @@
           <a:bodyPr/>
           <a:lstStyle/>
           <a:p>
-            <a:r>
-              <a:rPr lang="en-US" dirty="0"/>
-              <a:t/>
-            </a:r>
             <a:endParaRPr lang="en-US" dirty="0"/>
           </a:p>
         </p:txBody>
@@ -2001,6 +1714,11 @@
 <file path=ppt/slideMasters/slideMaster1.xml><?xml version="1.0" encoding="utf-8"?>
 <p:sldMaster xmlns:a="http://schemas.openxmlformats.org/drawingml/2006/main" xmlns:r="http://schemas.openxmlformats.org/officeDocument/2006/relationships" xmlns:p="http://schemas.openxmlformats.org/presentationml/2006/main">
   <p:cSld>
+    <p:bg>
+      <p:bgRef idx="1001">
+        <a:schemeClr val="bg1"/>
+      </p:bgRef>
+    </p:bg>
     <p:spTree>
       <p:nvGrpSpPr>
         <p:cNvPr id="1" name=""/>
@@ -2283,6 +2001,7 @@
         <a:solidFill>
           <a:srgbClr val="3D2EE8"/>
         </a:solidFill>
+        <a:effectLst/>
       </p:bgPr>
     </p:bg>
     <p:spTree>
@@ -2301,14 +2020,14 @@
       </p:grpSpPr>
       <p:pic>
         <p:nvPicPr>
-          <p:cNvPr id="2" name="Image 0" descr="/sessions/sleepy-zen-cray/mnt/outputs/deck_assets/logo_principal_blanco.png">    </p:cNvPr>
+          <p:cNvPr id="2" name="Image 0" descr="/sessions/sleepy-zen-cray/mnt/outputs/deck_assets/logo_principal_blanco.png"/>
           <p:cNvPicPr>
             <a:picLocks noChangeAspect="1"/>
           </p:cNvPicPr>
           <p:nvPr/>
         </p:nvPicPr>
         <p:blipFill>
-          <a:blip r:embed="rId1"/>
+          <a:blip r:embed="rId3"/>
           <a:stretch>
             <a:fillRect/>
           </a:stretch>
@@ -2344,11 +2063,11 @@
           <a:bodyPr wrap="square" rtlCol="0" anchor="ctr"/>
           <a:lstStyle/>
           <a:p>
-            <a:pPr algn="ctr" indent="0" marL="0">
-              <a:buNone/>
-            </a:pPr>
-            <a:r>
-              <a:rPr lang="en-US" sz="1400" spc="800" kern="0" dirty="0">
+            <a:pPr marL="0" indent="0" algn="ctr">
+              <a:buNone/>
+            </a:pPr>
+            <a:r>
+              <a:rPr lang="en-US" sz="1400" kern="0" spc="800" dirty="0">
                 <a:solidFill>
                   <a:srgbClr val="FFFFFF"/>
                 </a:solidFill>
@@ -2383,7 +2102,7 @@
           <a:bodyPr wrap="square" rtlCol="0" anchor="ctr"/>
           <a:lstStyle/>
           <a:p>
-            <a:pPr algn="ctr" indent="0" marL="0">
+            <a:pPr marL="0" indent="0" algn="ctr">
               <a:buNone/>
             </a:pPr>
             <a:r>
@@ -2422,7 +2141,7 @@
           <a:bodyPr wrap="square" rtlCol="0" anchor="ctr"/>
           <a:lstStyle/>
           <a:p>
-            <a:pPr algn="ctr" indent="0" marL="0">
+            <a:pPr marL="0" indent="0" algn="ctr">
               <a:buNone/>
             </a:pPr>
             <a:r>
@@ -2461,7 +2180,7 @@
           <a:bodyPr wrap="square" rtlCol="0" anchor="ctr"/>
           <a:lstStyle/>
           <a:p>
-            <a:pPr algn="ctr" indent="0" marL="0">
+            <a:pPr marL="0" indent="0" algn="ctr">
               <a:buNone/>
             </a:pPr>
             <a:r>
@@ -2481,14 +2200,14 @@
       </p:sp>
       <p:pic>
         <p:nvPicPr>
-          <p:cNvPr id="7" name="Image 1" descr="/sessions/sleepy-zen-cray/mnt/outputs/deck_assets/sello_linea_v1_05.png">    </p:cNvPr>
+          <p:cNvPr id="7" name="Image 1" descr="/sessions/sleepy-zen-cray/mnt/outputs/deck_assets/sello_linea_v1_05.png"/>
           <p:cNvPicPr>
             <a:picLocks noChangeAspect="1"/>
           </p:cNvPicPr>
           <p:nvPr/>
         </p:nvPicPr>
         <p:blipFill>
-          <a:blip r:embed="rId2"/>
+          <a:blip r:embed="rId4"/>
           <a:stretch>
             <a:fillRect/>
           </a:stretch>
@@ -2524,11 +2243,11 @@
           <a:bodyPr wrap="square" rtlCol="0" anchor="ctr"/>
           <a:lstStyle/>
           <a:p>
-            <a:pPr algn="ctr" indent="0" marL="0">
-              <a:buNone/>
-            </a:pPr>
-            <a:r>
-              <a:rPr lang="en-US" sz="1000" spc="400" kern="0" dirty="0">
+            <a:pPr marL="0" indent="0" algn="ctr">
+              <a:buNone/>
+            </a:pPr>
+            <a:r>
+              <a:rPr lang="en-US" sz="1000" kern="0" spc="400" dirty="0">
                 <a:solidFill>
                   <a:srgbClr val="FFFFFF"/>
                 </a:solidFill>
@@ -2558,6 +2277,7 @@
         <a:solidFill>
           <a:srgbClr val="FFFFFF"/>
         </a:solidFill>
+        <a:effectLst/>
       </p:bgPr>
     </p:bg>
     <p:spTree>
@@ -2595,11 +2315,11 @@
           <a:bodyPr wrap="square" rtlCol="0" anchor="ctr"/>
           <a:lstStyle/>
           <a:p>
-            <a:pPr indent="0" marL="0">
-              <a:buNone/>
-            </a:pPr>
-            <a:r>
-              <a:rPr lang="en-US" sz="900" b="1" spc="600" kern="0" dirty="0">
+            <a:pPr marL="0" indent="0">
+              <a:buNone/>
+            </a:pPr>
+            <a:r>
+              <a:rPr lang="en-US" sz="900" b="1" kern="0" spc="600" dirty="0">
                 <a:solidFill>
                   <a:srgbClr val="3D2EE8"/>
                 </a:solidFill>
@@ -2634,7 +2354,7 @@
           <a:bodyPr wrap="square" rtlCol="0" anchor="ctr"/>
           <a:lstStyle/>
           <a:p>
-            <a:pPr indent="0" marL="0">
+            <a:pPr marL="0" indent="0">
               <a:buNone/>
             </a:pPr>
             <a:r>
@@ -2700,7 +2420,7 @@
           <a:bodyPr wrap="square" rtlCol="0" anchor="ctr"/>
           <a:lstStyle/>
           <a:p>
-            <a:pPr algn="ctr" indent="0" marL="0">
+            <a:pPr marL="0" indent="0" algn="ctr">
               <a:buNone/>
             </a:pPr>
             <a:r>
@@ -2739,7 +2459,7 @@
           <a:bodyPr wrap="square" rtlCol="0" anchor="ctr"/>
           <a:lstStyle/>
           <a:p>
-            <a:pPr algn="ctr" indent="0" marL="0">
+            <a:pPr marL="0" indent="0" algn="ctr">
               <a:buNone/>
             </a:pPr>
             <a:r>
@@ -2805,7 +2525,7 @@
           <a:bodyPr wrap="square" rtlCol="0" anchor="ctr"/>
           <a:lstStyle/>
           <a:p>
-            <a:pPr algn="ctr" indent="0" marL="0">
+            <a:pPr marL="0" indent="0" algn="ctr">
               <a:buNone/>
             </a:pPr>
             <a:r>
@@ -2844,7 +2564,7 @@
           <a:bodyPr wrap="square" rtlCol="0" anchor="ctr"/>
           <a:lstStyle/>
           <a:p>
-            <a:pPr algn="ctr" indent="0" marL="0">
+            <a:pPr marL="0" indent="0" algn="ctr">
               <a:buNone/>
             </a:pPr>
             <a:r>
@@ -2910,7 +2630,7 @@
           <a:bodyPr wrap="square" rtlCol="0" anchor="ctr"/>
           <a:lstStyle/>
           <a:p>
-            <a:pPr algn="ctr" indent="0" marL="0">
+            <a:pPr marL="0" indent="0" algn="ctr">
               <a:buNone/>
             </a:pPr>
             <a:r>
@@ -2949,7 +2669,7 @@
           <a:bodyPr wrap="square" rtlCol="0" anchor="ctr"/>
           <a:lstStyle/>
           <a:p>
-            <a:pPr algn="ctr" indent="0" marL="0">
+            <a:pPr marL="0" indent="0" algn="ctr">
               <a:buNone/>
             </a:pPr>
             <a:r>
@@ -3015,7 +2735,7 @@
           <a:bodyPr wrap="square" rtlCol="0" anchor="ctr"/>
           <a:lstStyle/>
           <a:p>
-            <a:pPr algn="ctr" indent="0" marL="0">
+            <a:pPr marL="0" indent="0" algn="ctr">
               <a:buNone/>
             </a:pPr>
             <a:r>
@@ -3054,7 +2774,7 @@
           <a:bodyPr wrap="square" rtlCol="0" anchor="ctr"/>
           <a:lstStyle/>
           <a:p>
-            <a:pPr algn="ctr" indent="0" marL="0">
+            <a:pPr marL="0" indent="0" algn="ctr">
               <a:buNone/>
             </a:pPr>
             <a:r>
@@ -3120,7 +2840,7 @@
           <a:bodyPr wrap="square" rtlCol="0" anchor="ctr"/>
           <a:lstStyle/>
           <a:p>
-            <a:pPr algn="ctr" indent="0" marL="0">
+            <a:pPr marL="0" indent="0" algn="ctr">
               <a:buNone/>
             </a:pPr>
             <a:r>
@@ -3159,7 +2879,7 @@
           <a:bodyPr wrap="square" rtlCol="0" anchor="ctr"/>
           <a:lstStyle/>
           <a:p>
-            <a:pPr algn="ctr" indent="0" marL="0">
+            <a:pPr marL="0" indent="0" algn="ctr">
               <a:buNone/>
             </a:pPr>
             <a:r>
@@ -3225,7 +2945,7 @@
           <a:bodyPr wrap="square" rtlCol="0" anchor="ctr"/>
           <a:lstStyle/>
           <a:p>
-            <a:pPr algn="ctr" indent="0" marL="0">
+            <a:pPr marL="0" indent="0" algn="ctr">
               <a:buNone/>
             </a:pPr>
             <a:r>
@@ -3264,7 +2984,7 @@
           <a:bodyPr wrap="square" rtlCol="0" anchor="ctr"/>
           <a:lstStyle/>
           <a:p>
-            <a:pPr algn="ctr" indent="0" marL="0">
+            <a:pPr marL="0" indent="0" algn="ctr">
               <a:buNone/>
             </a:pPr>
             <a:r>
@@ -3330,7 +3050,7 @@
           <a:bodyPr wrap="square" rtlCol="0" anchor="ctr"/>
           <a:lstStyle/>
           <a:p>
-            <a:pPr algn="ctr" indent="0" marL="0">
+            <a:pPr marL="0" indent="0" algn="ctr">
               <a:buNone/>
             </a:pPr>
             <a:r>
@@ -3369,7 +3089,7 @@
           <a:bodyPr wrap="square" rtlCol="0" anchor="ctr"/>
           <a:lstStyle/>
           <a:p>
-            <a:pPr algn="ctr" indent="0" marL="0">
+            <a:pPr marL="0" indent="0" algn="ctr">
               <a:buNone/>
             </a:pPr>
             <a:r>
@@ -3435,7 +3155,7 @@
           <a:bodyPr wrap="square" rtlCol="0" anchor="ctr"/>
           <a:lstStyle/>
           <a:p>
-            <a:pPr algn="ctr" indent="0" marL="0">
+            <a:pPr marL="0" indent="0" algn="ctr">
               <a:buNone/>
             </a:pPr>
             <a:r>
@@ -3474,7 +3194,7 @@
           <a:bodyPr wrap="square" rtlCol="0" anchor="ctr"/>
           <a:lstStyle/>
           <a:p>
-            <a:pPr algn="ctr" indent="0" marL="0">
+            <a:pPr marL="0" indent="0" algn="ctr">
               <a:buNone/>
             </a:pPr>
             <a:r>
@@ -3494,14 +3214,14 @@
       </p:sp>
       <p:pic>
         <p:nvPicPr>
-          <p:cNvPr id="28" name="Image 0" descr="/sessions/sleepy-zen-cray/mnt/outputs/deck_assets/logo_var2_azul.png">    </p:cNvPr>
+          <p:cNvPr id="28" name="Image 0" descr="/sessions/sleepy-zen-cray/mnt/outputs/deck_assets/logo_var2_azul.png"/>
           <p:cNvPicPr>
             <a:picLocks noChangeAspect="1"/>
           </p:cNvPicPr>
           <p:nvPr/>
         </p:nvPicPr>
         <p:blipFill>
-          <a:blip r:embed="rId1"/>
+          <a:blip r:embed="rId3"/>
           <a:stretch>
             <a:fillRect/>
           </a:stretch>
@@ -3518,14 +3238,14 @@
       </p:pic>
       <p:pic>
         <p:nvPicPr>
-          <p:cNvPr id="29" name="Image 1" descr="/sessions/sleepy-zen-cray/mnt/outputs/deck_assets/sello_linea_v1_01.png">    </p:cNvPr>
+          <p:cNvPr id="29" name="Image 1" descr="/sessions/sleepy-zen-cray/mnt/outputs/deck_assets/sello_linea_v1_01.png"/>
           <p:cNvPicPr>
             <a:picLocks noChangeAspect="1"/>
           </p:cNvPicPr>
           <p:nvPr/>
         </p:nvPicPr>
         <p:blipFill>
-          <a:blip r:embed="rId2"/>
+          <a:blip r:embed="rId4"/>
           <a:stretch>
             <a:fillRect/>
           </a:stretch>
@@ -3561,7 +3281,7 @@
           <a:bodyPr wrap="square" rtlCol="0" anchor="ctr"/>
           <a:lstStyle/>
           <a:p>
-            <a:pPr indent="0" marL="0">
+            <a:pPr marL="0" indent="0">
               <a:buNone/>
             </a:pPr>
             <a:r>
@@ -3600,7 +3320,7 @@
           <a:bodyPr wrap="square" rtlCol="0" anchor="ctr"/>
           <a:lstStyle/>
           <a:p>
-            <a:pPr algn="r" indent="0" marL="0">
+            <a:pPr marL="0" indent="0" algn="r">
               <a:buNone/>
             </a:pPr>
             <a:r>
@@ -3634,6 +3354,7 @@
         <a:solidFill>
           <a:srgbClr val="FFFFFF"/>
         </a:solidFill>
+        <a:effectLst/>
       </p:bgPr>
     </p:bg>
     <p:spTree>
@@ -3671,11 +3392,11 @@
           <a:bodyPr wrap="square" rtlCol="0" anchor="ctr"/>
           <a:lstStyle/>
           <a:p>
-            <a:pPr indent="0" marL="0">
-              <a:buNone/>
-            </a:pPr>
-            <a:r>
-              <a:rPr lang="en-US" sz="900" b="1" spc="600" kern="0" dirty="0">
+            <a:pPr marL="0" indent="0">
+              <a:buNone/>
+            </a:pPr>
+            <a:r>
+              <a:rPr lang="en-US" sz="900" b="1" kern="0" spc="600" dirty="0">
                 <a:solidFill>
                   <a:srgbClr val="3D2EE8"/>
                 </a:solidFill>
@@ -3710,7 +3431,7 @@
           <a:bodyPr wrap="square" rtlCol="0" anchor="ctr"/>
           <a:lstStyle/>
           <a:p>
-            <a:pPr indent="0" marL="0">
+            <a:pPr marL="0" indent="0">
               <a:buNone/>
             </a:pPr>
             <a:r>
@@ -3776,7 +3497,7 @@
           <a:bodyPr wrap="square" rtlCol="0" anchor="ctr"/>
           <a:lstStyle/>
           <a:p>
-            <a:pPr indent="0" marL="0">
+            <a:pPr marL="0" indent="0">
               <a:buNone/>
             </a:pPr>
             <a:r>
@@ -3815,11 +3536,11 @@
           <a:bodyPr wrap="square" rtlCol="0" anchor="ctr"/>
           <a:lstStyle/>
           <a:p>
-            <a:pPr indent="0" marL="0">
-              <a:buNone/>
-            </a:pPr>
-            <a:r>
-              <a:rPr lang="en-US" sz="1200" b="1" spc="400" kern="0" dirty="0">
+            <a:pPr marL="0" indent="0">
+              <a:buNone/>
+            </a:pPr>
+            <a:r>
+              <a:rPr lang="en-US" sz="1200" b="1" kern="0" spc="400" dirty="0">
                 <a:solidFill>
                   <a:srgbClr val="3D2EE8"/>
                 </a:solidFill>
@@ -3854,7 +3575,7 @@
           <a:bodyPr wrap="square" rtlCol="0" anchor="t"/>
           <a:lstStyle/>
           <a:p>
-            <a:pPr indent="0" marL="0">
+            <a:pPr marL="0" indent="0">
               <a:lnSpc>
                 <a:spcPct val="130000"/>
               </a:lnSpc>
@@ -3874,7 +3595,7 @@
             <a:endParaRPr lang="en-US" sz="1800" dirty="0"/>
           </a:p>
           <a:p>
-            <a:pPr indent="0" marL="0">
+            <a:pPr marL="0" indent="0">
               <a:lnSpc>
                 <a:spcPct val="130000"/>
               </a:lnSpc>
@@ -3883,7 +3604,7 @@
             <a:endParaRPr lang="en-US" sz="1800" dirty="0"/>
           </a:p>
           <a:p>
-            <a:pPr indent="0" marL="0">
+            <a:pPr marL="0" indent="0">
               <a:lnSpc>
                 <a:spcPct val="130000"/>
               </a:lnSpc>
@@ -3903,7 +3624,7 @@
             <a:endParaRPr lang="en-US" sz="1800" dirty="0"/>
           </a:p>
           <a:p>
-            <a:pPr indent="0" marL="0">
+            <a:pPr marL="0" indent="0">
               <a:lnSpc>
                 <a:spcPct val="130000"/>
               </a:lnSpc>
@@ -3912,7 +3633,7 @@
             <a:endParaRPr lang="en-US" sz="1800" dirty="0"/>
           </a:p>
           <a:p>
-            <a:pPr indent="0" marL="0">
+            <a:pPr marL="0" indent="0">
               <a:lnSpc>
                 <a:spcPct val="130000"/>
               </a:lnSpc>
@@ -3932,7 +3653,7 @@
             <a:endParaRPr lang="en-US" sz="1800" dirty="0"/>
           </a:p>
           <a:p>
-            <a:pPr indent="0" marL="0">
+            <a:pPr marL="0" indent="0">
               <a:lnSpc>
                 <a:spcPct val="130000"/>
               </a:lnSpc>
@@ -3941,7 +3662,7 @@
             <a:endParaRPr lang="en-US" sz="1800" dirty="0"/>
           </a:p>
           <a:p>
-            <a:pPr indent="0" marL="0">
+            <a:pPr marL="0" indent="0">
               <a:lnSpc>
                 <a:spcPct val="130000"/>
               </a:lnSpc>
@@ -3964,14 +3685,14 @@
       </p:sp>
       <p:pic>
         <p:nvPicPr>
-          <p:cNvPr id="8" name="Image 0" descr="/sessions/sleepy-zen-cray/mnt/outputs/deck_assets/flor_01.png">    </p:cNvPr>
+          <p:cNvPr id="8" name="Image 0" descr="/sessions/sleepy-zen-cray/mnt/outputs/deck_assets/flor_01.png"/>
           <p:cNvPicPr>
             <a:picLocks noChangeAspect="1"/>
           </p:cNvPicPr>
           <p:nvPr/>
         </p:nvPicPr>
         <p:blipFill>
-          <a:blip r:embed="rId1">
+          <a:blip r:embed="rId3">
             <a:alphaModFix amt="30000"/>
           </a:blip>
           <a:stretch>
@@ -3990,14 +3711,14 @@
       </p:pic>
       <p:pic>
         <p:nvPicPr>
-          <p:cNvPr id="9" name="Image 1" descr="/sessions/sleepy-zen-cray/mnt/outputs/deck_assets/logo_var2_azul.png">    </p:cNvPr>
+          <p:cNvPr id="9" name="Image 1" descr="/sessions/sleepy-zen-cray/mnt/outputs/deck_assets/logo_var2_azul.png"/>
           <p:cNvPicPr>
             <a:picLocks noChangeAspect="1"/>
           </p:cNvPicPr>
           <p:nvPr/>
         </p:nvPicPr>
         <p:blipFill>
-          <a:blip r:embed="rId2"/>
+          <a:blip r:embed="rId4"/>
           <a:stretch>
             <a:fillRect/>
           </a:stretch>
@@ -4014,14 +3735,14 @@
       </p:pic>
       <p:pic>
         <p:nvPicPr>
-          <p:cNvPr id="10" name="Image 2" descr="/sessions/sleepy-zen-cray/mnt/outputs/deck_assets/sello_linea_v1_01.png">    </p:cNvPr>
+          <p:cNvPr id="10" name="Image 2" descr="/sessions/sleepy-zen-cray/mnt/outputs/deck_assets/sello_linea_v1_01.png"/>
           <p:cNvPicPr>
             <a:picLocks noChangeAspect="1"/>
           </p:cNvPicPr>
           <p:nvPr/>
         </p:nvPicPr>
         <p:blipFill>
-          <a:blip r:embed="rId3"/>
+          <a:blip r:embed="rId5"/>
           <a:stretch>
             <a:fillRect/>
           </a:stretch>
@@ -4057,7 +3778,7 @@
           <a:bodyPr wrap="square" rtlCol="0" anchor="ctr"/>
           <a:lstStyle/>
           <a:p>
-            <a:pPr indent="0" marL="0">
+            <a:pPr marL="0" indent="0">
               <a:buNone/>
             </a:pPr>
             <a:r>
@@ -4096,7 +3817,7 @@
           <a:bodyPr wrap="square" rtlCol="0" anchor="ctr"/>
           <a:lstStyle/>
           <a:p>
-            <a:pPr algn="r" indent="0" marL="0">
+            <a:pPr marL="0" indent="0" algn="r">
               <a:buNone/>
             </a:pPr>
             <a:r>
@@ -4130,6 +3851,7 @@
         <a:solidFill>
           <a:srgbClr val="FFFFFF"/>
         </a:solidFill>
+        <a:effectLst/>
       </p:bgPr>
     </p:bg>
     <p:spTree>
@@ -4167,11 +3889,11 @@
           <a:bodyPr wrap="square" rtlCol="0" anchor="ctr"/>
           <a:lstStyle/>
           <a:p>
-            <a:pPr indent="0" marL="0">
-              <a:buNone/>
-            </a:pPr>
-            <a:r>
-              <a:rPr lang="en-US" sz="900" b="1" spc="600" kern="0" dirty="0">
+            <a:pPr marL="0" indent="0">
+              <a:buNone/>
+            </a:pPr>
+            <a:r>
+              <a:rPr lang="en-US" sz="900" b="1" kern="0" spc="600" dirty="0">
                 <a:solidFill>
                   <a:srgbClr val="3D2EE8"/>
                 </a:solidFill>
@@ -4206,7 +3928,7 @@
           <a:bodyPr wrap="square" rtlCol="0" anchor="ctr"/>
           <a:lstStyle/>
           <a:p>
-            <a:pPr indent="0" marL="0">
+            <a:pPr marL="0" indent="0">
               <a:buNone/>
             </a:pPr>
             <a:r>
@@ -4272,7 +3994,7 @@
           <a:bodyPr wrap="square" rtlCol="0" anchor="ctr"/>
           <a:lstStyle/>
           <a:p>
-            <a:pPr algn="ctr" indent="0" marL="0">
+            <a:pPr marL="0" indent="0" algn="ctr">
               <a:buNone/>
             </a:pPr>
             <a:r>
@@ -4311,7 +4033,7 @@
           <a:bodyPr wrap="square" rtlCol="0" anchor="ctr"/>
           <a:lstStyle/>
           <a:p>
-            <a:pPr algn="ctr" indent="0" marL="0">
+            <a:pPr marL="0" indent="0" algn="ctr">
               <a:buNone/>
             </a:pPr>
             <a:r>
@@ -4377,7 +4099,7 @@
           <a:bodyPr wrap="square" rtlCol="0" anchor="ctr"/>
           <a:lstStyle/>
           <a:p>
-            <a:pPr algn="ctr" indent="0" marL="0">
+            <a:pPr marL="0" indent="0" algn="ctr">
               <a:buNone/>
             </a:pPr>
             <a:r>
@@ -4416,7 +4138,7 @@
           <a:bodyPr wrap="square" rtlCol="0" anchor="ctr"/>
           <a:lstStyle/>
           <a:p>
-            <a:pPr algn="ctr" indent="0" marL="0">
+            <a:pPr marL="0" indent="0" algn="ctr">
               <a:buNone/>
             </a:pPr>
             <a:r>
@@ -4482,7 +4204,7 @@
           <a:bodyPr wrap="square" rtlCol="0" anchor="ctr"/>
           <a:lstStyle/>
           <a:p>
-            <a:pPr algn="ctr" indent="0" marL="0">
+            <a:pPr marL="0" indent="0" algn="ctr">
               <a:buNone/>
             </a:pPr>
             <a:r>
@@ -4521,7 +4243,7 @@
           <a:bodyPr wrap="square" rtlCol="0" anchor="ctr"/>
           <a:lstStyle/>
           <a:p>
-            <a:pPr algn="ctr" indent="0" marL="0">
+            <a:pPr marL="0" indent="0" algn="ctr">
               <a:buNone/>
             </a:pPr>
             <a:r>
@@ -4587,7 +4309,7 @@
           <a:bodyPr wrap="square" rtlCol="0" anchor="ctr"/>
           <a:lstStyle/>
           <a:p>
-            <a:pPr algn="ctr" indent="0" marL="0">
+            <a:pPr marL="0" indent="0" algn="ctr">
               <a:buNone/>
             </a:pPr>
             <a:r>
@@ -4626,7 +4348,7 @@
           <a:bodyPr wrap="square" rtlCol="0" anchor="ctr"/>
           <a:lstStyle/>
           <a:p>
-            <a:pPr algn="ctr" indent="0" marL="0">
+            <a:pPr marL="0" indent="0" algn="ctr">
               <a:buNone/>
             </a:pPr>
             <a:r>
@@ -4692,7 +4414,7 @@
           <a:bodyPr wrap="square" rtlCol="0" anchor="ctr"/>
           <a:lstStyle/>
           <a:p>
-            <a:pPr algn="ctr" indent="0" marL="0">
+            <a:pPr marL="0" indent="0" algn="ctr">
               <a:buNone/>
             </a:pPr>
             <a:r>
@@ -4731,7 +4453,7 @@
           <a:bodyPr wrap="square" rtlCol="0" anchor="ctr"/>
           <a:lstStyle/>
           <a:p>
-            <a:pPr algn="ctr" indent="0" marL="0">
+            <a:pPr marL="0" indent="0" algn="ctr">
               <a:buNone/>
             </a:pPr>
             <a:r>
@@ -4797,7 +4519,7 @@
           <a:bodyPr wrap="square" rtlCol="0" anchor="ctr"/>
           <a:lstStyle/>
           <a:p>
-            <a:pPr algn="ctr" indent="0" marL="0">
+            <a:pPr marL="0" indent="0" algn="ctr">
               <a:buNone/>
             </a:pPr>
             <a:r>
@@ -4836,7 +4558,7 @@
           <a:bodyPr wrap="square" rtlCol="0" anchor="ctr"/>
           <a:lstStyle/>
           <a:p>
-            <a:pPr algn="ctr" indent="0" marL="0">
+            <a:pPr marL="0" indent="0" algn="ctr">
               <a:buNone/>
             </a:pPr>
             <a:r>
@@ -4902,7 +4624,7 @@
           <a:bodyPr wrap="square" rtlCol="0" anchor="ctr"/>
           <a:lstStyle/>
           <a:p>
-            <a:pPr algn="ctr" indent="0" marL="0">
+            <a:pPr marL="0" indent="0" algn="ctr">
               <a:buNone/>
             </a:pPr>
             <a:r>
@@ -4941,7 +4663,7 @@
           <a:bodyPr wrap="square" rtlCol="0" anchor="ctr"/>
           <a:lstStyle/>
           <a:p>
-            <a:pPr algn="ctr" indent="0" marL="0">
+            <a:pPr marL="0" indent="0" algn="ctr">
               <a:buNone/>
             </a:pPr>
             <a:r>
@@ -5007,7 +4729,7 @@
           <a:bodyPr wrap="square" rtlCol="0" anchor="ctr"/>
           <a:lstStyle/>
           <a:p>
-            <a:pPr algn="ctr" indent="0" marL="0">
+            <a:pPr marL="0" indent="0" algn="ctr">
               <a:buNone/>
             </a:pPr>
             <a:r>
@@ -5046,7 +4768,7 @@
           <a:bodyPr wrap="square" rtlCol="0" anchor="ctr"/>
           <a:lstStyle/>
           <a:p>
-            <a:pPr algn="ctr" indent="0" marL="0">
+            <a:pPr marL="0" indent="0" algn="ctr">
               <a:buNone/>
             </a:pPr>
             <a:r>
@@ -5112,7 +4834,7 @@
           <a:bodyPr wrap="square" rtlCol="0" anchor="ctr"/>
           <a:lstStyle/>
           <a:p>
-            <a:pPr algn="ctr" indent="0" marL="0">
+            <a:pPr marL="0" indent="0" algn="ctr">
               <a:buNone/>
             </a:pPr>
             <a:r>
@@ -5151,7 +4873,7 @@
           <a:bodyPr wrap="square" rtlCol="0" anchor="ctr"/>
           <a:lstStyle/>
           <a:p>
-            <a:pPr algn="ctr" indent="0" marL="0">
+            <a:pPr marL="0" indent="0" algn="ctr">
               <a:buNone/>
             </a:pPr>
             <a:r>
@@ -5217,7 +4939,7 @@
           <a:bodyPr wrap="square" rtlCol="0" anchor="ctr"/>
           <a:lstStyle/>
           <a:p>
-            <a:pPr algn="ctr" indent="0" marL="0">
+            <a:pPr marL="0" indent="0" algn="ctr">
               <a:buNone/>
             </a:pPr>
             <a:r>
@@ -5256,7 +4978,7 @@
           <a:bodyPr wrap="square" rtlCol="0" anchor="ctr"/>
           <a:lstStyle/>
           <a:p>
-            <a:pPr algn="ctr" indent="0" marL="0">
+            <a:pPr marL="0" indent="0" algn="ctr">
               <a:buNone/>
             </a:pPr>
             <a:r>
@@ -5322,7 +5044,7 @@
           <a:bodyPr wrap="square" rtlCol="0" anchor="ctr"/>
           <a:lstStyle/>
           <a:p>
-            <a:pPr algn="ctr" indent="0" marL="0">
+            <a:pPr marL="0" indent="0" algn="ctr">
               <a:buNone/>
             </a:pPr>
             <a:r>
@@ -5361,7 +5083,7 @@
           <a:bodyPr wrap="square" rtlCol="0" anchor="ctr"/>
           <a:lstStyle/>
           <a:p>
-            <a:pPr algn="ctr" indent="0" marL="0">
+            <a:pPr marL="0" indent="0" algn="ctr">
               <a:buNone/>
             </a:pPr>
             <a:r>
@@ -5427,7 +5149,7 @@
           <a:bodyPr wrap="square" rtlCol="0" anchor="ctr"/>
           <a:lstStyle/>
           <a:p>
-            <a:pPr algn="ctr" indent="0" marL="0">
+            <a:pPr marL="0" indent="0" algn="ctr">
               <a:buNone/>
             </a:pPr>
             <a:r>
@@ -5466,7 +5188,7 @@
           <a:bodyPr wrap="square" rtlCol="0" anchor="ctr"/>
           <a:lstStyle/>
           <a:p>
-            <a:pPr algn="ctr" indent="0" marL="0">
+            <a:pPr marL="0" indent="0" algn="ctr">
               <a:buNone/>
             </a:pPr>
             <a:r>
@@ -5486,14 +5208,14 @@
       </p:sp>
       <p:pic>
         <p:nvPicPr>
-          <p:cNvPr id="40" name="Image 0" descr="/sessions/sleepy-zen-cray/mnt/outputs/deck_assets/logo_var2_azul.png">    </p:cNvPr>
+          <p:cNvPr id="40" name="Image 0" descr="/sessions/sleepy-zen-cray/mnt/outputs/deck_assets/logo_var2_azul.png"/>
           <p:cNvPicPr>
             <a:picLocks noChangeAspect="1"/>
           </p:cNvPicPr>
           <p:nvPr/>
         </p:nvPicPr>
         <p:blipFill>
-          <a:blip r:embed="rId1"/>
+          <a:blip r:embed="rId3"/>
           <a:stretch>
             <a:fillRect/>
           </a:stretch>
@@ -5510,14 +5232,14 @@
       </p:pic>
       <p:pic>
         <p:nvPicPr>
-          <p:cNvPr id="41" name="Image 1" descr="/sessions/sleepy-zen-cray/mnt/outputs/deck_assets/sello_linea_v1_01.png">    </p:cNvPr>
+          <p:cNvPr id="41" name="Image 1" descr="/sessions/sleepy-zen-cray/mnt/outputs/deck_assets/sello_linea_v1_01.png"/>
           <p:cNvPicPr>
             <a:picLocks noChangeAspect="1"/>
           </p:cNvPicPr>
           <p:nvPr/>
         </p:nvPicPr>
         <p:blipFill>
-          <a:blip r:embed="rId2"/>
+          <a:blip r:embed="rId4"/>
           <a:stretch>
             <a:fillRect/>
           </a:stretch>
@@ -5553,7 +5275,7 @@
           <a:bodyPr wrap="square" rtlCol="0" anchor="ctr"/>
           <a:lstStyle/>
           <a:p>
-            <a:pPr indent="0" marL="0">
+            <a:pPr marL="0" indent="0">
               <a:buNone/>
             </a:pPr>
             <a:r>
@@ -5592,7 +5314,7 @@
           <a:bodyPr wrap="square" rtlCol="0" anchor="ctr"/>
           <a:lstStyle/>
           <a:p>
-            <a:pPr algn="r" indent="0" marL="0">
+            <a:pPr marL="0" indent="0" algn="r">
               <a:buNone/>
             </a:pPr>
             <a:r>
@@ -5626,6 +5348,7 @@
         <a:solidFill>
           <a:srgbClr val="FFFFFF"/>
         </a:solidFill>
+        <a:effectLst/>
       </p:bgPr>
     </p:bg>
     <p:spTree>
@@ -5663,11 +5386,11 @@
           <a:bodyPr wrap="square" rtlCol="0" anchor="ctr"/>
           <a:lstStyle/>
           <a:p>
-            <a:pPr indent="0" marL="0">
-              <a:buNone/>
-            </a:pPr>
-            <a:r>
-              <a:rPr lang="en-US" sz="900" b="1" spc="600" kern="0" dirty="0">
+            <a:pPr marL="0" indent="0">
+              <a:buNone/>
+            </a:pPr>
+            <a:r>
+              <a:rPr lang="en-US" sz="900" b="1" kern="0" spc="600" dirty="0">
                 <a:solidFill>
                   <a:srgbClr val="3D2EE8"/>
                 </a:solidFill>
@@ -5702,7 +5425,7 @@
           <a:bodyPr wrap="square" rtlCol="0" anchor="ctr"/>
           <a:lstStyle/>
           <a:p>
-            <a:pPr indent="0" marL="0">
+            <a:pPr marL="0" indent="0">
               <a:buNone/>
             </a:pPr>
             <a:r>
@@ -5741,7 +5464,7 @@
           <a:bodyPr wrap="square" rtlCol="0" anchor="t"/>
           <a:lstStyle/>
           <a:p>
-            <a:pPr indent="0" marL="0">
+            <a:pPr marL="0" indent="0">
               <a:lnSpc>
                 <a:spcPct val="140000"/>
               </a:lnSpc>
@@ -5761,7 +5484,7 @@
             <a:endParaRPr lang="en-US" sz="1400" dirty="0"/>
           </a:p>
           <a:p>
-            <a:pPr indent="0" marL="0">
+            <a:pPr marL="0" indent="0">
               <a:lnSpc>
                 <a:spcPct val="140000"/>
               </a:lnSpc>
@@ -5770,7 +5493,7 @@
             <a:endParaRPr lang="en-US" sz="1400" dirty="0"/>
           </a:p>
           <a:p>
-            <a:pPr indent="0" marL="0">
+            <a:pPr marL="0" indent="0">
               <a:lnSpc>
                 <a:spcPct val="140000"/>
               </a:lnSpc>
@@ -5790,7 +5513,7 @@
             <a:endParaRPr lang="en-US" sz="1400" dirty="0"/>
           </a:p>
           <a:p>
-            <a:pPr indent="0" marL="0">
+            <a:pPr marL="0" indent="0">
               <a:lnSpc>
                 <a:spcPct val="140000"/>
               </a:lnSpc>
@@ -5810,7 +5533,7 @@
             <a:endParaRPr lang="en-US" sz="1400" dirty="0"/>
           </a:p>
           <a:p>
-            <a:pPr indent="0" marL="0">
+            <a:pPr marL="0" indent="0">
               <a:lnSpc>
                 <a:spcPct val="140000"/>
               </a:lnSpc>
@@ -5830,7 +5553,7 @@
             <a:endParaRPr lang="en-US" sz="1400" dirty="0"/>
           </a:p>
           <a:p>
-            <a:pPr indent="0" marL="0">
+            <a:pPr marL="0" indent="0">
               <a:lnSpc>
                 <a:spcPct val="140000"/>
               </a:lnSpc>
@@ -5839,7 +5562,7 @@
             <a:endParaRPr lang="en-US" sz="1400" dirty="0"/>
           </a:p>
           <a:p>
-            <a:pPr indent="0" marL="0">
+            <a:pPr marL="0" indent="0">
               <a:lnSpc>
                 <a:spcPct val="140000"/>
               </a:lnSpc>
@@ -5908,7 +5631,7 @@
           <a:bodyPr wrap="square" rtlCol="0" anchor="ctr"/>
           <a:lstStyle/>
           <a:p>
-            <a:pPr algn="ctr" indent="0" marL="0">
+            <a:pPr marL="0" indent="0" algn="ctr">
               <a:buNone/>
             </a:pPr>
             <a:r>
@@ -5947,7 +5670,7 @@
           <a:bodyPr wrap="square" rtlCol="0" anchor="ctr"/>
           <a:lstStyle/>
           <a:p>
-            <a:pPr algn="ctr" indent="0" marL="0">
+            <a:pPr marL="0" indent="0" algn="ctr">
               <a:buNone/>
             </a:pPr>
             <a:r>
@@ -5986,7 +5709,7 @@
           <a:bodyPr wrap="square" rtlCol="0" anchor="ctr"/>
           <a:lstStyle/>
           <a:p>
-            <a:pPr algn="ctr" indent="0" marL="0">
+            <a:pPr marL="0" indent="0" algn="ctr">
               <a:buNone/>
             </a:pPr>
             <a:r>
@@ -6006,14 +5729,14 @@
       </p:sp>
       <p:pic>
         <p:nvPicPr>
-          <p:cNvPr id="9" name="Image 0" descr="/sessions/sleepy-zen-cray/mnt/outputs/deck_assets/logo_var2_azul.png">    </p:cNvPr>
+          <p:cNvPr id="9" name="Image 0" descr="/sessions/sleepy-zen-cray/mnt/outputs/deck_assets/logo_var2_azul.png"/>
           <p:cNvPicPr>
             <a:picLocks noChangeAspect="1"/>
           </p:cNvPicPr>
           <p:nvPr/>
         </p:nvPicPr>
         <p:blipFill>
-          <a:blip r:embed="rId1"/>
+          <a:blip r:embed="rId3"/>
           <a:stretch>
             <a:fillRect/>
           </a:stretch>
@@ -6030,14 +5753,14 @@
       </p:pic>
       <p:pic>
         <p:nvPicPr>
-          <p:cNvPr id="10" name="Image 1" descr="/sessions/sleepy-zen-cray/mnt/outputs/deck_assets/sello_linea_v1_01.png">    </p:cNvPr>
+          <p:cNvPr id="10" name="Image 1" descr="/sessions/sleepy-zen-cray/mnt/outputs/deck_assets/sello_linea_v1_01.png"/>
           <p:cNvPicPr>
             <a:picLocks noChangeAspect="1"/>
           </p:cNvPicPr>
           <p:nvPr/>
         </p:nvPicPr>
         <p:blipFill>
-          <a:blip r:embed="rId2"/>
+          <a:blip r:embed="rId4"/>
           <a:stretch>
             <a:fillRect/>
           </a:stretch>
@@ -6073,7 +5796,7 @@
           <a:bodyPr wrap="square" rtlCol="0" anchor="ctr"/>
           <a:lstStyle/>
           <a:p>
-            <a:pPr indent="0" marL="0">
+            <a:pPr marL="0" indent="0">
               <a:buNone/>
             </a:pPr>
             <a:r>
@@ -6112,7 +5835,7 @@
           <a:bodyPr wrap="square" rtlCol="0" anchor="ctr"/>
           <a:lstStyle/>
           <a:p>
-            <a:pPr algn="r" indent="0" marL="0">
+            <a:pPr marL="0" indent="0" algn="r">
               <a:buNone/>
             </a:pPr>
             <a:r>
@@ -6146,6 +5869,7 @@
         <a:solidFill>
           <a:srgbClr val="FFFFFF"/>
         </a:solidFill>
+        <a:effectLst/>
       </p:bgPr>
     </p:bg>
     <p:spTree>
@@ -6183,11 +5907,11 @@
           <a:bodyPr wrap="square" rtlCol="0" anchor="ctr"/>
           <a:lstStyle/>
           <a:p>
-            <a:pPr indent="0" marL="0">
-              <a:buNone/>
-            </a:pPr>
-            <a:r>
-              <a:rPr lang="en-US" sz="900" b="1" spc="600" kern="0" dirty="0">
+            <a:pPr marL="0" indent="0">
+              <a:buNone/>
+            </a:pPr>
+            <a:r>
+              <a:rPr lang="en-US" sz="900" b="1" kern="0" spc="600" dirty="0">
                 <a:solidFill>
                   <a:srgbClr val="3D2EE8"/>
                 </a:solidFill>
@@ -6222,7 +5946,7 @@
           <a:bodyPr wrap="square" rtlCol="0" anchor="ctr"/>
           <a:lstStyle/>
           <a:p>
-            <a:pPr indent="0" marL="0">
+            <a:pPr marL="0" indent="0">
               <a:buNone/>
             </a:pPr>
             <a:r>
@@ -6288,7 +6012,7 @@
           <a:bodyPr wrap="square" rtlCol="0" anchor="ctr"/>
           <a:lstStyle/>
           <a:p>
-            <a:pPr indent="0" marL="0">
+            <a:pPr marL="0" indent="0">
               <a:buNone/>
             </a:pPr>
             <a:r>
@@ -6327,11 +6051,11 @@
           <a:bodyPr wrap="square" rtlCol="0" anchor="ctr"/>
           <a:lstStyle/>
           <a:p>
-            <a:pPr indent="0" marL="0">
-              <a:buNone/>
-            </a:pPr>
-            <a:r>
-              <a:rPr lang="en-US" sz="1200" b="1" spc="400" kern="0" dirty="0">
+            <a:pPr marL="0" indent="0">
+              <a:buNone/>
+            </a:pPr>
+            <a:r>
+              <a:rPr lang="en-US" sz="1200" b="1" kern="0" spc="400" dirty="0">
                 <a:solidFill>
                   <a:srgbClr val="3D2EE8"/>
                 </a:solidFill>
@@ -6366,7 +6090,7 @@
           <a:bodyPr wrap="square" rtlCol="0" anchor="t"/>
           <a:lstStyle/>
           <a:p>
-            <a:pPr indent="0" marL="0">
+            <a:pPr marL="0" indent="0">
               <a:lnSpc>
                 <a:spcPct val="130000"/>
               </a:lnSpc>
@@ -6386,7 +6110,7 @@
             <a:endParaRPr lang="en-US" sz="1800" dirty="0"/>
           </a:p>
           <a:p>
-            <a:pPr indent="0" marL="0">
+            <a:pPr marL="0" indent="0">
               <a:lnSpc>
                 <a:spcPct val="130000"/>
               </a:lnSpc>
@@ -6395,7 +6119,7 @@
             <a:endParaRPr lang="en-US" sz="1800" dirty="0"/>
           </a:p>
           <a:p>
-            <a:pPr indent="0" marL="0">
+            <a:pPr marL="0" indent="0">
               <a:lnSpc>
                 <a:spcPct val="130000"/>
               </a:lnSpc>
@@ -6415,7 +6139,7 @@
             <a:endParaRPr lang="en-US" sz="1800" dirty="0"/>
           </a:p>
           <a:p>
-            <a:pPr indent="0" marL="0">
+            <a:pPr marL="0" indent="0">
               <a:lnSpc>
                 <a:spcPct val="130000"/>
               </a:lnSpc>
@@ -6424,7 +6148,7 @@
             <a:endParaRPr lang="en-US" sz="1800" dirty="0"/>
           </a:p>
           <a:p>
-            <a:pPr indent="0" marL="0">
+            <a:pPr marL="0" indent="0">
               <a:lnSpc>
                 <a:spcPct val="130000"/>
               </a:lnSpc>
@@ -6444,7 +6168,7 @@
             <a:endParaRPr lang="en-US" sz="1800" dirty="0"/>
           </a:p>
           <a:p>
-            <a:pPr indent="0" marL="0">
+            <a:pPr marL="0" indent="0">
               <a:lnSpc>
                 <a:spcPct val="130000"/>
               </a:lnSpc>
@@ -6453,7 +6177,7 @@
             <a:endParaRPr lang="en-US" sz="1800" dirty="0"/>
           </a:p>
           <a:p>
-            <a:pPr indent="0" marL="0">
+            <a:pPr marL="0" indent="0">
               <a:lnSpc>
                 <a:spcPct val="130000"/>
               </a:lnSpc>
@@ -6476,14 +6200,14 @@
       </p:sp>
       <p:pic>
         <p:nvPicPr>
-          <p:cNvPr id="8" name="Image 0" descr="/sessions/sleepy-zen-cray/mnt/outputs/deck_assets/flor_01.png">    </p:cNvPr>
+          <p:cNvPr id="8" name="Image 0" descr="/sessions/sleepy-zen-cray/mnt/outputs/deck_assets/flor_01.png"/>
           <p:cNvPicPr>
             <a:picLocks noChangeAspect="1"/>
           </p:cNvPicPr>
           <p:nvPr/>
         </p:nvPicPr>
         <p:blipFill>
-          <a:blip r:embed="rId1">
+          <a:blip r:embed="rId3">
             <a:alphaModFix amt="30000"/>
           </a:blip>
           <a:stretch>
@@ -6502,14 +6226,14 @@
       </p:pic>
       <p:pic>
         <p:nvPicPr>
-          <p:cNvPr id="9" name="Image 1" descr="/sessions/sleepy-zen-cray/mnt/outputs/deck_assets/logo_var2_azul.png">    </p:cNvPr>
+          <p:cNvPr id="9" name="Image 1" descr="/sessions/sleepy-zen-cray/mnt/outputs/deck_assets/logo_var2_azul.png"/>
           <p:cNvPicPr>
             <a:picLocks noChangeAspect="1"/>
           </p:cNvPicPr>
           <p:nvPr/>
         </p:nvPicPr>
         <p:blipFill>
-          <a:blip r:embed="rId2"/>
+          <a:blip r:embed="rId4"/>
           <a:stretch>
             <a:fillRect/>
           </a:stretch>
@@ -6526,14 +6250,14 @@
       </p:pic>
       <p:pic>
         <p:nvPicPr>
-          <p:cNvPr id="10" name="Image 2" descr="/sessions/sleepy-zen-cray/mnt/outputs/deck_assets/sello_linea_v1_01.png">    </p:cNvPr>
+          <p:cNvPr id="10" name="Image 2" descr="/sessions/sleepy-zen-cray/mnt/outputs/deck_assets/sello_linea_v1_01.png"/>
           <p:cNvPicPr>
             <a:picLocks noChangeAspect="1"/>
           </p:cNvPicPr>
           <p:nvPr/>
         </p:nvPicPr>
         <p:blipFill>
-          <a:blip r:embed="rId3"/>
+          <a:blip r:embed="rId5"/>
           <a:stretch>
             <a:fillRect/>
           </a:stretch>
@@ -6569,7 +6293,7 @@
           <a:bodyPr wrap="square" rtlCol="0" anchor="ctr"/>
           <a:lstStyle/>
           <a:p>
-            <a:pPr indent="0" marL="0">
+            <a:pPr marL="0" indent="0">
               <a:buNone/>
             </a:pPr>
             <a:r>
@@ -6608,7 +6332,7 @@
           <a:bodyPr wrap="square" rtlCol="0" anchor="ctr"/>
           <a:lstStyle/>
           <a:p>
-            <a:pPr algn="r" indent="0" marL="0">
+            <a:pPr marL="0" indent="0" algn="r">
               <a:buNone/>
             </a:pPr>
             <a:r>
@@ -6642,6 +6366,7 @@
         <a:solidFill>
           <a:srgbClr val="FFFFFF"/>
         </a:solidFill>
+        <a:effectLst/>
       </p:bgPr>
     </p:bg>
     <p:spTree>
@@ -6679,11 +6404,11 @@
           <a:bodyPr wrap="square" rtlCol="0" anchor="ctr"/>
           <a:lstStyle/>
           <a:p>
-            <a:pPr indent="0" marL="0">
-              <a:buNone/>
-            </a:pPr>
-            <a:r>
-              <a:rPr lang="en-US" sz="900" b="1" spc="600" kern="0" dirty="0">
+            <a:pPr marL="0" indent="0">
+              <a:buNone/>
+            </a:pPr>
+            <a:r>
+              <a:rPr lang="en-US" sz="900" b="1" kern="0" spc="600" dirty="0">
                 <a:solidFill>
                   <a:srgbClr val="3D2EE8"/>
                 </a:solidFill>
@@ -6718,7 +6443,7 @@
           <a:bodyPr wrap="square" rtlCol="0" anchor="ctr"/>
           <a:lstStyle/>
           <a:p>
-            <a:pPr indent="0" marL="0">
+            <a:pPr marL="0" indent="0">
               <a:buNone/>
             </a:pPr>
             <a:r>
@@ -6784,7 +6509,7 @@
           <a:bodyPr wrap="square" rtlCol="0" anchor="ctr"/>
           <a:lstStyle/>
           <a:p>
-            <a:pPr indent="0" marL="0">
+            <a:pPr marL="0" indent="0">
               <a:buNone/>
             </a:pPr>
             <a:r>
@@ -6823,7 +6548,7 @@
           <a:bodyPr wrap="square" rtlCol="0" anchor="ctr"/>
           <a:lstStyle/>
           <a:p>
-            <a:pPr indent="0" marL="0">
+            <a:pPr marL="0" indent="0">
               <a:buNone/>
             </a:pPr>
             <a:r>
@@ -6862,7 +6587,7 @@
           <a:bodyPr wrap="square" rtlCol="0" anchor="ctr"/>
           <a:lstStyle/>
           <a:p>
-            <a:pPr indent="0" marL="0">
+            <a:pPr marL="0" indent="0">
               <a:buNone/>
             </a:pPr>
             <a:r>
@@ -6901,7 +6626,7 @@
           <a:bodyPr wrap="square" rtlCol="0" anchor="ctr"/>
           <a:lstStyle/>
           <a:p>
-            <a:pPr indent="0" marL="0">
+            <a:pPr marL="0" indent="0">
               <a:buNone/>
             </a:pPr>
             <a:r>
@@ -6940,7 +6665,7 @@
           <a:bodyPr wrap="square" rtlCol="0" anchor="ctr"/>
           <a:lstStyle/>
           <a:p>
-            <a:pPr indent="0" marL="0">
+            <a:pPr marL="0" indent="0">
               <a:buNone/>
             </a:pPr>
             <a:r>
@@ -6979,7 +6704,7 @@
           <a:bodyPr wrap="square" rtlCol="0" anchor="ctr"/>
           <a:lstStyle/>
           <a:p>
-            <a:pPr indent="0" marL="0">
+            <a:pPr marL="0" indent="0">
               <a:buNone/>
             </a:pPr>
             <a:r>
@@ -7018,7 +6743,7 @@
           <a:bodyPr wrap="square" rtlCol="0" anchor="ctr"/>
           <a:lstStyle/>
           <a:p>
-            <a:pPr indent="0" marL="0">
+            <a:pPr marL="0" indent="0">
               <a:buNone/>
             </a:pPr>
             <a:r>
@@ -7057,7 +6782,7 @@
           <a:bodyPr wrap="square" rtlCol="0" anchor="ctr"/>
           <a:lstStyle/>
           <a:p>
-            <a:pPr indent="0" marL="0">
+            <a:pPr marL="0" indent="0">
               <a:buNone/>
             </a:pPr>
             <a:r>
@@ -7096,7 +6821,7 @@
           <a:bodyPr wrap="square" rtlCol="0" anchor="ctr"/>
           <a:lstStyle/>
           <a:p>
-            <a:pPr indent="0" marL="0">
+            <a:pPr marL="0" indent="0">
               <a:buNone/>
             </a:pPr>
             <a:r>
@@ -7135,7 +6860,7 @@
           <a:bodyPr wrap="square" rtlCol="0" anchor="ctr"/>
           <a:lstStyle/>
           <a:p>
-            <a:pPr indent="0" marL="0">
+            <a:pPr marL="0" indent="0">
               <a:buNone/>
             </a:pPr>
             <a:r>
@@ -7174,7 +6899,7 @@
           <a:bodyPr wrap="square" rtlCol="0" anchor="ctr"/>
           <a:lstStyle/>
           <a:p>
-            <a:pPr indent="0" marL="0">
+            <a:pPr marL="0" indent="0">
               <a:buNone/>
             </a:pPr>
             <a:r>
@@ -7213,7 +6938,7 @@
           <a:bodyPr wrap="square" rtlCol="0" anchor="ctr"/>
           <a:lstStyle/>
           <a:p>
-            <a:pPr indent="0" marL="0">
+            <a:pPr marL="0" indent="0">
               <a:buNone/>
             </a:pPr>
             <a:r>
@@ -7252,7 +6977,7 @@
           <a:bodyPr wrap="square" rtlCol="0" anchor="ctr"/>
           <a:lstStyle/>
           <a:p>
-            <a:pPr indent="0" marL="0">
+            <a:pPr marL="0" indent="0">
               <a:buNone/>
             </a:pPr>
             <a:r>
@@ -7291,7 +7016,7 @@
           <a:bodyPr wrap="square" rtlCol="0" anchor="ctr"/>
           <a:lstStyle/>
           <a:p>
-            <a:pPr indent="0" marL="0">
+            <a:pPr marL="0" indent="0">
               <a:buNone/>
             </a:pPr>
             <a:r>
@@ -7330,7 +7055,7 @@
           <a:bodyPr wrap="square" rtlCol="0" anchor="ctr"/>
           <a:lstStyle/>
           <a:p>
-            <a:pPr indent="0" marL="0">
+            <a:pPr marL="0" indent="0">
               <a:buNone/>
             </a:pPr>
             <a:r>
@@ -7369,7 +7094,7 @@
           <a:bodyPr wrap="square" rtlCol="0" anchor="ctr"/>
           <a:lstStyle/>
           <a:p>
-            <a:pPr indent="0" marL="0">
+            <a:pPr marL="0" indent="0">
               <a:buNone/>
             </a:pPr>
             <a:r>
@@ -7408,7 +7133,7 @@
           <a:bodyPr wrap="square" rtlCol="0" anchor="ctr"/>
           <a:lstStyle/>
           <a:p>
-            <a:pPr indent="0" marL="0">
+            <a:pPr marL="0" indent="0">
               <a:buNone/>
             </a:pPr>
             <a:r>
@@ -7447,7 +7172,7 @@
           <a:bodyPr wrap="square" rtlCol="0" anchor="ctr"/>
           <a:lstStyle/>
           <a:p>
-            <a:pPr indent="0" marL="0">
+            <a:pPr marL="0" indent="0">
               <a:buNone/>
             </a:pPr>
             <a:r>
@@ -7467,14 +7192,14 @@
       </p:sp>
       <p:pic>
         <p:nvPicPr>
-          <p:cNvPr id="23" name="Image 0" descr="/sessions/sleepy-zen-cray/mnt/outputs/deck_assets/logo_var2_azul.png">    </p:cNvPr>
+          <p:cNvPr id="23" name="Image 0" descr="/sessions/sleepy-zen-cray/mnt/outputs/deck_assets/logo_var2_azul.png"/>
           <p:cNvPicPr>
             <a:picLocks noChangeAspect="1"/>
           </p:cNvPicPr>
           <p:nvPr/>
         </p:nvPicPr>
         <p:blipFill>
-          <a:blip r:embed="rId1"/>
+          <a:blip r:embed="rId3"/>
           <a:stretch>
             <a:fillRect/>
           </a:stretch>
@@ -7491,14 +7216,14 @@
       </p:pic>
       <p:pic>
         <p:nvPicPr>
-          <p:cNvPr id="24" name="Image 1" descr="/sessions/sleepy-zen-cray/mnt/outputs/deck_assets/sello_linea_v1_01.png">    </p:cNvPr>
+          <p:cNvPr id="24" name="Image 1" descr="/sessions/sleepy-zen-cray/mnt/outputs/deck_assets/sello_linea_v1_01.png"/>
           <p:cNvPicPr>
             <a:picLocks noChangeAspect="1"/>
           </p:cNvPicPr>
           <p:nvPr/>
         </p:nvPicPr>
         <p:blipFill>
-          <a:blip r:embed="rId2"/>
+          <a:blip r:embed="rId4"/>
           <a:stretch>
             <a:fillRect/>
           </a:stretch>
@@ -7534,7 +7259,7 @@
           <a:bodyPr wrap="square" rtlCol="0" anchor="ctr"/>
           <a:lstStyle/>
           <a:p>
-            <a:pPr indent="0" marL="0">
+            <a:pPr marL="0" indent="0">
               <a:buNone/>
             </a:pPr>
             <a:r>
@@ -7573,7 +7298,7 @@
           <a:bodyPr wrap="square" rtlCol="0" anchor="ctr"/>
           <a:lstStyle/>
           <a:p>
-            <a:pPr algn="r" indent="0" marL="0">
+            <a:pPr marL="0" indent="0" algn="r">
               <a:buNone/>
             </a:pPr>
             <a:r>
@@ -7607,6 +7332,7 @@
         <a:solidFill>
           <a:srgbClr val="FF5C5C"/>
         </a:solidFill>
+        <a:effectLst/>
       </p:bgPr>
     </p:bg>
     <p:spTree>
@@ -7625,14 +7351,14 @@
       </p:grpSpPr>
       <p:pic>
         <p:nvPicPr>
-          <p:cNvPr id="2" name="Image 0" descr="/sessions/sleepy-zen-cray/mnt/outputs/deck_assets/logo_principal_blanco.png">    </p:cNvPr>
+          <p:cNvPr id="2" name="Image 0" descr="/sessions/sleepy-zen-cray/mnt/outputs/deck_assets/logo_principal_blanco.png"/>
           <p:cNvPicPr>
             <a:picLocks noChangeAspect="1"/>
           </p:cNvPicPr>
           <p:nvPr/>
         </p:nvPicPr>
         <p:blipFill>
-          <a:blip r:embed="rId1"/>
+          <a:blip r:embed="rId3"/>
           <a:stretch>
             <a:fillRect/>
           </a:stretch>
@@ -7668,11 +7394,11 @@
           <a:bodyPr wrap="square" rtlCol="0" anchor="ctr"/>
           <a:lstStyle/>
           <a:p>
-            <a:pPr algn="ctr" indent="0" marL="0">
-              <a:buNone/>
-            </a:pPr>
-            <a:r>
-              <a:rPr lang="en-US" sz="1000" b="1" spc="800" kern="0" dirty="0">
+            <a:pPr marL="0" indent="0" algn="ctr">
+              <a:buNone/>
+            </a:pPr>
+            <a:r>
+              <a:rPr lang="en-US" sz="1000" b="1" kern="0" spc="800" dirty="0">
                 <a:solidFill>
                   <a:srgbClr val="FFFFFF"/>
                 </a:solidFill>
@@ -7707,7 +7433,7 @@
           <a:bodyPr wrap="square" rtlCol="0" anchor="ctr"/>
           <a:lstStyle/>
           <a:p>
-            <a:pPr algn="ctr" indent="0" marL="0">
+            <a:pPr marL="0" indent="0" algn="ctr">
               <a:buNone/>
             </a:pPr>
             <a:r>
@@ -7773,7 +7499,7 @@
           <a:bodyPr wrap="square" rtlCol="0" anchor="t"/>
           <a:lstStyle/>
           <a:p>
-            <a:pPr indent="0" marL="0">
+            <a:pPr marL="0" indent="0">
               <a:lnSpc>
                 <a:spcPct val="150000"/>
               </a:lnSpc>
@@ -7793,7 +7519,7 @@
             <a:endParaRPr lang="en-US" sz="1500" dirty="0"/>
           </a:p>
           <a:p>
-            <a:pPr indent="0" marL="0">
+            <a:pPr marL="0" indent="0">
               <a:lnSpc>
                 <a:spcPct val="150000"/>
               </a:lnSpc>
@@ -7813,7 +7539,7 @@
             <a:endParaRPr lang="en-US" sz="1500" dirty="0"/>
           </a:p>
           <a:p>
-            <a:pPr indent="0" marL="0">
+            <a:pPr marL="0" indent="0">
               <a:lnSpc>
                 <a:spcPct val="150000"/>
               </a:lnSpc>
@@ -7833,7 +7559,7 @@
             <a:endParaRPr lang="en-US" sz="1500" dirty="0"/>
           </a:p>
           <a:p>
-            <a:pPr indent="0" marL="0">
+            <a:pPr marL="0" indent="0">
               <a:lnSpc>
                 <a:spcPct val="150000"/>
               </a:lnSpc>
@@ -7853,7 +7579,7 @@
             <a:endParaRPr lang="en-US" sz="1500" dirty="0"/>
           </a:p>
           <a:p>
-            <a:pPr indent="0" marL="0">
+            <a:pPr marL="0" indent="0">
               <a:lnSpc>
                 <a:spcPct val="150000"/>
               </a:lnSpc>
@@ -7873,7 +7599,7 @@
             <a:endParaRPr lang="en-US" sz="1500" dirty="0"/>
           </a:p>
           <a:p>
-            <a:pPr indent="0" marL="0">
+            <a:pPr marL="0" indent="0">
               <a:lnSpc>
                 <a:spcPct val="150000"/>
               </a:lnSpc>
@@ -7915,11 +7641,11 @@
           <a:bodyPr wrap="square" rtlCol="0" anchor="ctr"/>
           <a:lstStyle/>
           <a:p>
-            <a:pPr algn="ctr" indent="0" marL="0">
-              <a:buNone/>
-            </a:pPr>
-            <a:r>
-              <a:rPr lang="en-US" sz="1200" b="1" spc="600" kern="0" dirty="0">
+            <a:pPr marL="0" indent="0" algn="ctr">
+              <a:buNone/>
+            </a:pPr>
+            <a:r>
+              <a:rPr lang="en-US" sz="1200" b="1" kern="0" spc="600" dirty="0">
                 <a:solidFill>
                   <a:srgbClr val="FFFFFF"/>
                 </a:solidFill>
@@ -7954,7 +7680,7 @@
           <a:bodyPr wrap="square" rtlCol="0" anchor="ctr"/>
           <a:lstStyle/>
           <a:p>
-            <a:pPr algn="ctr" indent="0" marL="0">
+            <a:pPr marL="0" indent="0" algn="ctr">
               <a:buNone/>
             </a:pPr>
             <a:r>
@@ -7988,6 +7714,7 @@
         <a:solidFill>
           <a:srgbClr val="3D2EE8"/>
         </a:solidFill>
+        <a:effectLst/>
       </p:bgPr>
     </p:bg>
     <p:spTree>
@@ -8025,7 +7752,7 @@
           <a:bodyPr wrap="square" rtlCol="0" anchor="ctr"/>
           <a:lstStyle/>
           <a:p>
-            <a:pPr algn="ctr" indent="0" marL="0">
+            <a:pPr marL="0" indent="0" algn="ctr">
               <a:buNone/>
             </a:pPr>
             <a:r>
@@ -8064,7 +7791,7 @@
           <a:bodyPr wrap="square" rtlCol="0" anchor="ctr"/>
           <a:lstStyle/>
           <a:p>
-            <a:pPr algn="ctr" indent="0" marL="0">
+            <a:pPr marL="0" indent="0" algn="ctr">
               <a:buNone/>
             </a:pPr>
             <a:r>
@@ -8084,14 +7811,14 @@
       </p:sp>
       <p:pic>
         <p:nvPicPr>
-          <p:cNvPr id="4" name="Image 0" descr="/sessions/sleepy-zen-cray/mnt/outputs/deck_assets/logo_principal_blanco.png">    </p:cNvPr>
+          <p:cNvPr id="4" name="Image 0" descr="/sessions/sleepy-zen-cray/mnt/outputs/deck_assets/logo_principal_blanco.png"/>
           <p:cNvPicPr>
             <a:picLocks noChangeAspect="1"/>
           </p:cNvPicPr>
           <p:nvPr/>
         </p:nvPicPr>
         <p:blipFill>
-          <a:blip r:embed="rId1"/>
+          <a:blip r:embed="rId3"/>
           <a:stretch>
             <a:fillRect/>
           </a:stretch>
@@ -8127,11 +7854,11 @@
           <a:bodyPr wrap="square" rtlCol="0" anchor="ctr"/>
           <a:lstStyle/>
           <a:p>
-            <a:pPr algn="ctr" indent="0" marL="0">
-              <a:buNone/>
-            </a:pPr>
-            <a:r>
-              <a:rPr lang="en-US" sz="1000" b="1" spc="600" kern="0" dirty="0">
+            <a:pPr marL="0" indent="0" algn="ctr">
+              <a:buNone/>
+            </a:pPr>
+            <a:r>
+              <a:rPr lang="en-US" sz="1000" b="1" kern="0" spc="600" dirty="0">
                 <a:solidFill>
                   <a:srgbClr val="FFFFFF"/>
                 </a:solidFill>
@@ -8161,6 +7888,7 @@
         <a:solidFill>
           <a:srgbClr val="FFFFFF"/>
         </a:solidFill>
+        <a:effectLst/>
       </p:bgPr>
     </p:bg>
     <p:spTree>
@@ -8198,11 +7926,11 @@
           <a:bodyPr wrap="square" rtlCol="0" anchor="ctr"/>
           <a:lstStyle/>
           <a:p>
-            <a:pPr indent="0" marL="0">
-              <a:buNone/>
-            </a:pPr>
-            <a:r>
-              <a:rPr lang="en-US" sz="900" b="1" spc="600" kern="0" dirty="0">
+            <a:pPr marL="0" indent="0">
+              <a:buNone/>
+            </a:pPr>
+            <a:r>
+              <a:rPr lang="en-US" sz="900" b="1" kern="0" spc="600" dirty="0">
                 <a:solidFill>
                   <a:srgbClr val="3D2EE8"/>
                 </a:solidFill>
@@ -8237,7 +7965,7 @@
           <a:bodyPr wrap="square" rtlCol="0" anchor="ctr"/>
           <a:lstStyle/>
           <a:p>
-            <a:pPr indent="0" marL="0">
+            <a:pPr marL="0" indent="0">
               <a:buNone/>
             </a:pPr>
             <a:r>
@@ -8276,7 +8004,7 @@
           <a:bodyPr wrap="square" rtlCol="0" anchor="t"/>
           <a:lstStyle/>
           <a:p>
-            <a:pPr indent="0" marL="0">
+            <a:pPr marL="0" indent="0">
               <a:lnSpc>
                 <a:spcPct val="140000"/>
               </a:lnSpc>
@@ -8296,7 +8024,7 @@
             <a:endParaRPr lang="en-US" sz="1600" dirty="0"/>
           </a:p>
           <a:p>
-            <a:pPr indent="0" marL="0">
+            <a:pPr marL="0" indent="0">
               <a:lnSpc>
                 <a:spcPct val="140000"/>
               </a:lnSpc>
@@ -8305,7 +8033,7 @@
             <a:endParaRPr lang="en-US" sz="1600" dirty="0"/>
           </a:p>
           <a:p>
-            <a:pPr indent="0" marL="0">
+            <a:pPr marL="0" indent="0">
               <a:lnSpc>
                 <a:spcPct val="140000"/>
               </a:lnSpc>
@@ -8325,7 +8053,7 @@
             <a:endParaRPr lang="en-US" sz="1600" dirty="0"/>
           </a:p>
           <a:p>
-            <a:pPr indent="0" marL="0">
+            <a:pPr marL="0" indent="0">
               <a:lnSpc>
                 <a:spcPct val="140000"/>
               </a:lnSpc>
@@ -8334,7 +8062,7 @@
             <a:endParaRPr lang="en-US" sz="1600" dirty="0"/>
           </a:p>
           <a:p>
-            <a:pPr indent="0" marL="0">
+            <a:pPr marL="0" indent="0">
               <a:lnSpc>
                 <a:spcPct val="140000"/>
               </a:lnSpc>
@@ -8357,14 +8085,14 @@
       </p:sp>
       <p:pic>
         <p:nvPicPr>
-          <p:cNvPr id="5" name="Image 0" descr="/sessions/sleepy-zen-cray/mnt/outputs/deck_assets/sello_relleno_v1_01.png">    </p:cNvPr>
+          <p:cNvPr id="5" name="Image 0" descr="/sessions/sleepy-zen-cray/mnt/outputs/deck_assets/sello_relleno_v1_01.png"/>
           <p:cNvPicPr>
             <a:picLocks noChangeAspect="1"/>
           </p:cNvPicPr>
           <p:nvPr/>
         </p:nvPicPr>
         <p:blipFill>
-          <a:blip r:embed="rId1"/>
+          <a:blip r:embed="rId3"/>
           <a:stretch>
             <a:fillRect/>
           </a:stretch>
@@ -8381,14 +8109,14 @@
       </p:pic>
       <p:pic>
         <p:nvPicPr>
-          <p:cNvPr id="6" name="Image 1" descr="/sessions/sleepy-zen-cray/mnt/outputs/deck_assets/sello_linea_v1_01.png">    </p:cNvPr>
+          <p:cNvPr id="6" name="Image 1" descr="/sessions/sleepy-zen-cray/mnt/outputs/deck_assets/sello_linea_v1_01.png"/>
           <p:cNvPicPr>
             <a:picLocks noChangeAspect="1"/>
           </p:cNvPicPr>
           <p:nvPr/>
         </p:nvPicPr>
         <p:blipFill>
-          <a:blip r:embed="rId2"/>
+          <a:blip r:embed="rId4"/>
           <a:stretch>
             <a:fillRect/>
           </a:stretch>
@@ -8424,7 +8152,7 @@
           <a:bodyPr wrap="square" rtlCol="0" anchor="ctr"/>
           <a:lstStyle/>
           <a:p>
-            <a:pPr indent="0" marL="0">
+            <a:pPr marL="0" indent="0">
               <a:buNone/>
             </a:pPr>
             <a:r>
@@ -8463,7 +8191,7 @@
           <a:bodyPr wrap="square" rtlCol="0" anchor="ctr"/>
           <a:lstStyle/>
           <a:p>
-            <a:pPr algn="r" indent="0" marL="0">
+            <a:pPr marL="0" indent="0" algn="r">
               <a:buNone/>
             </a:pPr>
             <a:r>
@@ -8497,6 +8225,7 @@
         <a:solidFill>
           <a:srgbClr val="FFFFFF"/>
         </a:solidFill>
+        <a:effectLst/>
       </p:bgPr>
     </p:bg>
     <p:spTree>
@@ -8534,11 +8263,11 @@
           <a:bodyPr wrap="square" rtlCol="0" anchor="ctr"/>
           <a:lstStyle/>
           <a:p>
-            <a:pPr indent="0" marL="0">
-              <a:buNone/>
-            </a:pPr>
-            <a:r>
-              <a:rPr lang="en-US" sz="900" b="1" spc="600" kern="0" dirty="0">
+            <a:pPr marL="0" indent="0">
+              <a:buNone/>
+            </a:pPr>
+            <a:r>
+              <a:rPr lang="en-US" sz="900" b="1" kern="0" spc="600" dirty="0">
                 <a:solidFill>
                   <a:srgbClr val="3D2EE8"/>
                 </a:solidFill>
@@ -8573,7 +8302,7 @@
           <a:bodyPr wrap="square" rtlCol="0" anchor="ctr"/>
           <a:lstStyle/>
           <a:p>
-            <a:pPr indent="0" marL="0">
+            <a:pPr marL="0" indent="0">
               <a:buNone/>
             </a:pPr>
             <a:r>
@@ -8612,7 +8341,7 @@
           <a:bodyPr wrap="square" rtlCol="0" anchor="t"/>
           <a:lstStyle/>
           <a:p>
-            <a:pPr indent="0" marL="0">
+            <a:pPr marL="0" indent="0">
               <a:lnSpc>
                 <a:spcPct val="140000"/>
               </a:lnSpc>
@@ -8632,7 +8361,7 @@
             <a:endParaRPr lang="en-US" sz="1400" dirty="0"/>
           </a:p>
           <a:p>
-            <a:pPr indent="0" marL="0">
+            <a:pPr marL="0" indent="0">
               <a:lnSpc>
                 <a:spcPct val="140000"/>
               </a:lnSpc>
@@ -8641,7 +8370,7 @@
             <a:endParaRPr lang="en-US" sz="1400" dirty="0"/>
           </a:p>
           <a:p>
-            <a:pPr indent="0" marL="0">
+            <a:pPr marL="0" indent="0">
               <a:lnSpc>
                 <a:spcPct val="140000"/>
               </a:lnSpc>
@@ -8661,7 +8390,7 @@
             <a:endParaRPr lang="en-US" sz="1400" dirty="0"/>
           </a:p>
           <a:p>
-            <a:pPr indent="0" marL="0">
+            <a:pPr marL="0" indent="0">
               <a:lnSpc>
                 <a:spcPct val="140000"/>
               </a:lnSpc>
@@ -8681,7 +8410,7 @@
             <a:endParaRPr lang="en-US" sz="1400" dirty="0"/>
           </a:p>
           <a:p>
-            <a:pPr indent="0" marL="0">
+            <a:pPr marL="0" indent="0">
               <a:lnSpc>
                 <a:spcPct val="140000"/>
               </a:lnSpc>
@@ -8701,7 +8430,7 @@
             <a:endParaRPr lang="en-US" sz="1400" dirty="0"/>
           </a:p>
           <a:p>
-            <a:pPr indent="0" marL="0">
+            <a:pPr marL="0" indent="0">
               <a:lnSpc>
                 <a:spcPct val="140000"/>
               </a:lnSpc>
@@ -8721,7 +8450,7 @@
             <a:endParaRPr lang="en-US" sz="1400" dirty="0"/>
           </a:p>
           <a:p>
-            <a:pPr indent="0" marL="0">
+            <a:pPr marL="0" indent="0">
               <a:lnSpc>
                 <a:spcPct val="140000"/>
               </a:lnSpc>
@@ -8730,7 +8459,7 @@
             <a:endParaRPr lang="en-US" sz="1400" dirty="0"/>
           </a:p>
           <a:p>
-            <a:pPr indent="0" marL="0">
+            <a:pPr marL="0" indent="0">
               <a:lnSpc>
                 <a:spcPct val="140000"/>
               </a:lnSpc>
@@ -8799,7 +8528,7 @@
           <a:bodyPr wrap="square" rtlCol="0" anchor="ctr"/>
           <a:lstStyle/>
           <a:p>
-            <a:pPr algn="ctr" indent="0" marL="0">
+            <a:pPr marL="0" indent="0" algn="ctr">
               <a:buNone/>
             </a:pPr>
             <a:r>
@@ -8838,7 +8567,7 @@
           <a:bodyPr wrap="square" rtlCol="0" anchor="ctr"/>
           <a:lstStyle/>
           <a:p>
-            <a:pPr algn="ctr" indent="0" marL="0">
+            <a:pPr marL="0" indent="0" algn="ctr">
               <a:buNone/>
             </a:pPr>
             <a:r>
@@ -8877,7 +8606,7 @@
           <a:bodyPr wrap="square" rtlCol="0" anchor="ctr"/>
           <a:lstStyle/>
           <a:p>
-            <a:pPr algn="ctr" indent="0" marL="0">
+            <a:pPr marL="0" indent="0" algn="ctr">
               <a:buNone/>
             </a:pPr>
             <a:r>
@@ -8897,14 +8626,14 @@
       </p:sp>
       <p:pic>
         <p:nvPicPr>
-          <p:cNvPr id="9" name="Image 0" descr="/sessions/sleepy-zen-cray/mnt/outputs/deck_assets/logo_var2_azul.png">    </p:cNvPr>
+          <p:cNvPr id="9" name="Image 0" descr="/sessions/sleepy-zen-cray/mnt/outputs/deck_assets/logo_var2_azul.png"/>
           <p:cNvPicPr>
             <a:picLocks noChangeAspect="1"/>
           </p:cNvPicPr>
           <p:nvPr/>
         </p:nvPicPr>
         <p:blipFill>
-          <a:blip r:embed="rId1"/>
+          <a:blip r:embed="rId3"/>
           <a:stretch>
             <a:fillRect/>
           </a:stretch>
@@ -8921,14 +8650,14 @@
       </p:pic>
       <p:pic>
         <p:nvPicPr>
-          <p:cNvPr id="10" name="Image 1" descr="/sessions/sleepy-zen-cray/mnt/outputs/deck_assets/sello_linea_v1_01.png">    </p:cNvPr>
+          <p:cNvPr id="10" name="Image 1" descr="/sessions/sleepy-zen-cray/mnt/outputs/deck_assets/sello_linea_v1_01.png"/>
           <p:cNvPicPr>
             <a:picLocks noChangeAspect="1"/>
           </p:cNvPicPr>
           <p:nvPr/>
         </p:nvPicPr>
         <p:blipFill>
-          <a:blip r:embed="rId2"/>
+          <a:blip r:embed="rId4"/>
           <a:stretch>
             <a:fillRect/>
           </a:stretch>
@@ -8964,7 +8693,7 @@
           <a:bodyPr wrap="square" rtlCol="0" anchor="ctr"/>
           <a:lstStyle/>
           <a:p>
-            <a:pPr indent="0" marL="0">
+            <a:pPr marL="0" indent="0">
               <a:buNone/>
             </a:pPr>
             <a:r>
@@ -9003,7 +8732,7 @@
           <a:bodyPr wrap="square" rtlCol="0" anchor="ctr"/>
           <a:lstStyle/>
           <a:p>
-            <a:pPr algn="r" indent="0" marL="0">
+            <a:pPr marL="0" indent="0" algn="r">
               <a:buNone/>
             </a:pPr>
             <a:r>
@@ -9037,6 +8766,7 @@
         <a:solidFill>
           <a:srgbClr val="FFFFFF"/>
         </a:solidFill>
+        <a:effectLst/>
       </p:bgPr>
     </p:bg>
     <p:spTree>
@@ -9074,11 +8804,11 @@
           <a:bodyPr wrap="square" rtlCol="0" anchor="ctr"/>
           <a:lstStyle/>
           <a:p>
-            <a:pPr indent="0" marL="0">
-              <a:buNone/>
-            </a:pPr>
-            <a:r>
-              <a:rPr lang="en-US" sz="900" b="1" spc="600" kern="0" dirty="0">
+            <a:pPr marL="0" indent="0">
+              <a:buNone/>
+            </a:pPr>
+            <a:r>
+              <a:rPr lang="en-US" sz="900" b="1" kern="0" spc="600" dirty="0">
                 <a:solidFill>
                   <a:srgbClr val="3D2EE8"/>
                 </a:solidFill>
@@ -9113,7 +8843,7 @@
           <a:bodyPr wrap="square" rtlCol="0" anchor="ctr"/>
           <a:lstStyle/>
           <a:p>
-            <a:pPr indent="0" marL="0">
+            <a:pPr marL="0" indent="0">
               <a:buNone/>
             </a:pPr>
             <a:r>
@@ -9179,7 +8909,7 @@
           <a:bodyPr wrap="square" rtlCol="0" anchor="ctr"/>
           <a:lstStyle/>
           <a:p>
-            <a:pPr algn="ctr" indent="0" marL="0">
+            <a:pPr marL="0" indent="0" algn="ctr">
               <a:buNone/>
             </a:pPr>
             <a:r>
@@ -9218,7 +8948,7 @@
           <a:bodyPr wrap="square" rtlCol="0" anchor="ctr"/>
           <a:lstStyle/>
           <a:p>
-            <a:pPr algn="ctr" indent="0" marL="0">
+            <a:pPr marL="0" indent="0" algn="ctr">
               <a:buNone/>
             </a:pPr>
             <a:r>
@@ -9284,7 +9014,7 @@
           <a:bodyPr wrap="square" rtlCol="0" anchor="ctr"/>
           <a:lstStyle/>
           <a:p>
-            <a:pPr algn="ctr" indent="0" marL="0">
+            <a:pPr marL="0" indent="0" algn="ctr">
               <a:buNone/>
             </a:pPr>
             <a:r>
@@ -9323,7 +9053,7 @@
           <a:bodyPr wrap="square" rtlCol="0" anchor="ctr"/>
           <a:lstStyle/>
           <a:p>
-            <a:pPr algn="ctr" indent="0" marL="0">
+            <a:pPr marL="0" indent="0" algn="ctr">
               <a:buNone/>
             </a:pPr>
             <a:r>
@@ -9389,7 +9119,7 @@
           <a:bodyPr wrap="square" rtlCol="0" anchor="ctr"/>
           <a:lstStyle/>
           <a:p>
-            <a:pPr algn="ctr" indent="0" marL="0">
+            <a:pPr marL="0" indent="0" algn="ctr">
               <a:buNone/>
             </a:pPr>
             <a:r>
@@ -9428,7 +9158,7 @@
           <a:bodyPr wrap="square" rtlCol="0" anchor="ctr"/>
           <a:lstStyle/>
           <a:p>
-            <a:pPr algn="ctr" indent="0" marL="0">
+            <a:pPr marL="0" indent="0" algn="ctr">
               <a:buNone/>
             </a:pPr>
             <a:r>
@@ -9494,7 +9224,7 @@
           <a:bodyPr wrap="square" rtlCol="0" anchor="ctr"/>
           <a:lstStyle/>
           <a:p>
-            <a:pPr algn="ctr" indent="0" marL="0">
+            <a:pPr marL="0" indent="0" algn="ctr">
               <a:buNone/>
             </a:pPr>
             <a:r>
@@ -9533,7 +9263,7 @@
           <a:bodyPr wrap="square" rtlCol="0" anchor="ctr"/>
           <a:lstStyle/>
           <a:p>
-            <a:pPr algn="ctr" indent="0" marL="0">
+            <a:pPr marL="0" indent="0" algn="ctr">
               <a:buNone/>
             </a:pPr>
             <a:r>
@@ -9599,7 +9329,7 @@
           <a:bodyPr wrap="square" rtlCol="0" anchor="ctr"/>
           <a:lstStyle/>
           <a:p>
-            <a:pPr algn="ctr" indent="0" marL="0">
+            <a:pPr marL="0" indent="0" algn="ctr">
               <a:buNone/>
             </a:pPr>
             <a:r>
@@ -9638,7 +9368,7 @@
           <a:bodyPr wrap="square" rtlCol="0" anchor="ctr"/>
           <a:lstStyle/>
           <a:p>
-            <a:pPr algn="ctr" indent="0" marL="0">
+            <a:pPr marL="0" indent="0" algn="ctr">
               <a:buNone/>
             </a:pPr>
             <a:r>
@@ -9704,7 +9434,7 @@
           <a:bodyPr wrap="square" rtlCol="0" anchor="ctr"/>
           <a:lstStyle/>
           <a:p>
-            <a:pPr algn="ctr" indent="0" marL="0">
+            <a:pPr marL="0" indent="0" algn="ctr">
               <a:buNone/>
             </a:pPr>
             <a:r>
@@ -9743,7 +9473,7 @@
           <a:bodyPr wrap="square" rtlCol="0" anchor="ctr"/>
           <a:lstStyle/>
           <a:p>
-            <a:pPr algn="ctr" indent="0" marL="0">
+            <a:pPr marL="0" indent="0" algn="ctr">
               <a:buNone/>
             </a:pPr>
             <a:r>
@@ -9809,7 +9539,7 @@
           <a:bodyPr wrap="square" rtlCol="0" anchor="ctr"/>
           <a:lstStyle/>
           <a:p>
-            <a:pPr algn="ctr" indent="0" marL="0">
+            <a:pPr marL="0" indent="0" algn="ctr">
               <a:buNone/>
             </a:pPr>
             <a:r>
@@ -9848,7 +9578,7 @@
           <a:bodyPr wrap="square" rtlCol="0" anchor="ctr"/>
           <a:lstStyle/>
           <a:p>
-            <a:pPr algn="ctr" indent="0" marL="0">
+            <a:pPr marL="0" indent="0" algn="ctr">
               <a:buNone/>
             </a:pPr>
             <a:r>
@@ -9914,7 +9644,7 @@
           <a:bodyPr wrap="square" rtlCol="0" anchor="ctr"/>
           <a:lstStyle/>
           <a:p>
-            <a:pPr algn="ctr" indent="0" marL="0">
+            <a:pPr marL="0" indent="0" algn="ctr">
               <a:buNone/>
             </a:pPr>
             <a:r>
@@ -9953,7 +9683,7 @@
           <a:bodyPr wrap="square" rtlCol="0" anchor="ctr"/>
           <a:lstStyle/>
           <a:p>
-            <a:pPr algn="ctr" indent="0" marL="0">
+            <a:pPr marL="0" indent="0" algn="ctr">
               <a:buNone/>
             </a:pPr>
             <a:r>
@@ -9973,14 +9703,14 @@
       </p:sp>
       <p:pic>
         <p:nvPicPr>
-          <p:cNvPr id="28" name="Image 0" descr="/sessions/sleepy-zen-cray/mnt/outputs/deck_assets/logo_var2_azul.png">    </p:cNvPr>
+          <p:cNvPr id="28" name="Image 0" descr="/sessions/sleepy-zen-cray/mnt/outputs/deck_assets/logo_var2_azul.png"/>
           <p:cNvPicPr>
             <a:picLocks noChangeAspect="1"/>
           </p:cNvPicPr>
           <p:nvPr/>
         </p:nvPicPr>
         <p:blipFill>
-          <a:blip r:embed="rId1"/>
+          <a:blip r:embed="rId3"/>
           <a:stretch>
             <a:fillRect/>
           </a:stretch>
@@ -9997,14 +9727,14 @@
       </p:pic>
       <p:pic>
         <p:nvPicPr>
-          <p:cNvPr id="29" name="Image 1" descr="/sessions/sleepy-zen-cray/mnt/outputs/deck_assets/sello_linea_v1_01.png">    </p:cNvPr>
+          <p:cNvPr id="29" name="Image 1" descr="/sessions/sleepy-zen-cray/mnt/outputs/deck_assets/sello_linea_v1_01.png"/>
           <p:cNvPicPr>
             <a:picLocks noChangeAspect="1"/>
           </p:cNvPicPr>
           <p:nvPr/>
         </p:nvPicPr>
         <p:blipFill>
-          <a:blip r:embed="rId2"/>
+          <a:blip r:embed="rId4"/>
           <a:stretch>
             <a:fillRect/>
           </a:stretch>
@@ -10040,7 +9770,7 @@
           <a:bodyPr wrap="square" rtlCol="0" anchor="ctr"/>
           <a:lstStyle/>
           <a:p>
-            <a:pPr indent="0" marL="0">
+            <a:pPr marL="0" indent="0">
               <a:buNone/>
             </a:pPr>
             <a:r>
@@ -10079,7 +9809,7 @@
           <a:bodyPr wrap="square" rtlCol="0" anchor="ctr"/>
           <a:lstStyle/>
           <a:p>
-            <a:pPr algn="r" indent="0" marL="0">
+            <a:pPr marL="0" indent="0" algn="r">
               <a:buNone/>
             </a:pPr>
             <a:r>
@@ -10113,6 +9843,7 @@
         <a:solidFill>
           <a:srgbClr val="FFFFFF"/>
         </a:solidFill>
+        <a:effectLst/>
       </p:bgPr>
     </p:bg>
     <p:spTree>
@@ -10150,11 +9881,11 @@
           <a:bodyPr wrap="square" rtlCol="0" anchor="ctr"/>
           <a:lstStyle/>
           <a:p>
-            <a:pPr indent="0" marL="0">
-              <a:buNone/>
-            </a:pPr>
-            <a:r>
-              <a:rPr lang="en-US" sz="900" b="1" spc="600" kern="0" dirty="0">
+            <a:pPr marL="0" indent="0">
+              <a:buNone/>
+            </a:pPr>
+            <a:r>
+              <a:rPr lang="en-US" sz="900" b="1" kern="0" spc="600" dirty="0">
                 <a:solidFill>
                   <a:srgbClr val="3D2EE8"/>
                 </a:solidFill>
@@ -10189,7 +9920,7 @@
           <a:bodyPr wrap="square" rtlCol="0" anchor="ctr"/>
           <a:lstStyle/>
           <a:p>
-            <a:pPr indent="0" marL="0">
+            <a:pPr marL="0" indent="0">
               <a:buNone/>
             </a:pPr>
             <a:r>
@@ -10255,7 +9986,7 @@
           <a:bodyPr wrap="square" rtlCol="0" anchor="ctr"/>
           <a:lstStyle/>
           <a:p>
-            <a:pPr algn="ctr" indent="0" marL="0">
+            <a:pPr marL="0" indent="0" algn="ctr">
               <a:buNone/>
             </a:pPr>
             <a:r>
@@ -10294,7 +10025,7 @@
           <a:bodyPr wrap="square" rtlCol="0" anchor="ctr"/>
           <a:lstStyle/>
           <a:p>
-            <a:pPr algn="ctr" indent="0" marL="0">
+            <a:pPr marL="0" indent="0" algn="ctr">
               <a:buNone/>
             </a:pPr>
             <a:r>
@@ -10360,7 +10091,7 @@
           <a:bodyPr wrap="square" rtlCol="0" anchor="ctr"/>
           <a:lstStyle/>
           <a:p>
-            <a:pPr algn="ctr" indent="0" marL="0">
+            <a:pPr marL="0" indent="0" algn="ctr">
               <a:buNone/>
             </a:pPr>
             <a:r>
@@ -10399,7 +10130,7 @@
           <a:bodyPr wrap="square" rtlCol="0" anchor="ctr"/>
           <a:lstStyle/>
           <a:p>
-            <a:pPr algn="ctr" indent="0" marL="0">
+            <a:pPr marL="0" indent="0" algn="ctr">
               <a:buNone/>
             </a:pPr>
             <a:r>
@@ -10465,7 +10196,7 @@
           <a:bodyPr wrap="square" rtlCol="0" anchor="ctr"/>
           <a:lstStyle/>
           <a:p>
-            <a:pPr algn="ctr" indent="0" marL="0">
+            <a:pPr marL="0" indent="0" algn="ctr">
               <a:buNone/>
             </a:pPr>
             <a:r>
@@ -10504,7 +10235,7 @@
           <a:bodyPr wrap="square" rtlCol="0" anchor="ctr"/>
           <a:lstStyle/>
           <a:p>
-            <a:pPr algn="ctr" indent="0" marL="0">
+            <a:pPr marL="0" indent="0" algn="ctr">
               <a:buNone/>
             </a:pPr>
             <a:r>
@@ -10570,7 +10301,7 @@
           <a:bodyPr wrap="square" rtlCol="0" anchor="ctr"/>
           <a:lstStyle/>
           <a:p>
-            <a:pPr algn="ctr" indent="0" marL="0">
+            <a:pPr marL="0" indent="0" algn="ctr">
               <a:buNone/>
             </a:pPr>
             <a:r>
@@ -10609,7 +10340,7 @@
           <a:bodyPr wrap="square" rtlCol="0" anchor="ctr"/>
           <a:lstStyle/>
           <a:p>
-            <a:pPr algn="ctr" indent="0" marL="0">
+            <a:pPr marL="0" indent="0" algn="ctr">
               <a:buNone/>
             </a:pPr>
             <a:r>
@@ -10629,14 +10360,14 @@
       </p:sp>
       <p:pic>
         <p:nvPicPr>
-          <p:cNvPr id="16" name="Image 0" descr="/sessions/sleepy-zen-cray/mnt/outputs/deck_assets/logo_var2_azul.png">    </p:cNvPr>
+          <p:cNvPr id="16" name="Image 0" descr="/sessions/sleepy-zen-cray/mnt/outputs/deck_assets/logo_var2_azul.png"/>
           <p:cNvPicPr>
             <a:picLocks noChangeAspect="1"/>
           </p:cNvPicPr>
           <p:nvPr/>
         </p:nvPicPr>
         <p:blipFill>
-          <a:blip r:embed="rId1"/>
+          <a:blip r:embed="rId3"/>
           <a:stretch>
             <a:fillRect/>
           </a:stretch>
@@ -10653,14 +10384,14 @@
       </p:pic>
       <p:pic>
         <p:nvPicPr>
-          <p:cNvPr id="17" name="Image 1" descr="/sessions/sleepy-zen-cray/mnt/outputs/deck_assets/sello_linea_v1_01.png">    </p:cNvPr>
+          <p:cNvPr id="17" name="Image 1" descr="/sessions/sleepy-zen-cray/mnt/outputs/deck_assets/sello_linea_v1_01.png"/>
           <p:cNvPicPr>
             <a:picLocks noChangeAspect="1"/>
           </p:cNvPicPr>
           <p:nvPr/>
         </p:nvPicPr>
         <p:blipFill>
-          <a:blip r:embed="rId2"/>
+          <a:blip r:embed="rId4"/>
           <a:stretch>
             <a:fillRect/>
           </a:stretch>
@@ -10696,7 +10427,7 @@
           <a:bodyPr wrap="square" rtlCol="0" anchor="ctr"/>
           <a:lstStyle/>
           <a:p>
-            <a:pPr indent="0" marL="0">
+            <a:pPr marL="0" indent="0">
               <a:buNone/>
             </a:pPr>
             <a:r>
@@ -10735,7 +10466,7 @@
           <a:bodyPr wrap="square" rtlCol="0" anchor="ctr"/>
           <a:lstStyle/>
           <a:p>
-            <a:pPr algn="r" indent="0" marL="0">
+            <a:pPr marL="0" indent="0" algn="r">
               <a:buNone/>
             </a:pPr>
             <a:r>
@@ -10769,6 +10500,7 @@
         <a:solidFill>
           <a:srgbClr val="FFFFFF"/>
         </a:solidFill>
+        <a:effectLst/>
       </p:bgPr>
     </p:bg>
     <p:spTree>
@@ -10806,11 +10538,11 @@
           <a:bodyPr wrap="square" rtlCol="0" anchor="ctr"/>
           <a:lstStyle/>
           <a:p>
-            <a:pPr indent="0" marL="0">
-              <a:buNone/>
-            </a:pPr>
-            <a:r>
-              <a:rPr lang="en-US" sz="900" b="1" spc="600" kern="0" dirty="0">
+            <a:pPr marL="0" indent="0">
+              <a:buNone/>
+            </a:pPr>
+            <a:r>
+              <a:rPr lang="en-US" sz="900" b="1" kern="0" spc="600" dirty="0">
                 <a:solidFill>
                   <a:srgbClr val="3D2EE8"/>
                 </a:solidFill>
@@ -10845,7 +10577,7 @@
           <a:bodyPr wrap="square" rtlCol="0" anchor="ctr"/>
           <a:lstStyle/>
           <a:p>
-            <a:pPr indent="0" marL="0">
+            <a:pPr marL="0" indent="0">
               <a:buNone/>
             </a:pPr>
             <a:r>
@@ -10884,7 +10616,7 @@
           <a:bodyPr wrap="square" rtlCol="0" anchor="t"/>
           <a:lstStyle/>
           <a:p>
-            <a:pPr indent="0" marL="0">
+            <a:pPr marL="0" indent="0">
               <a:lnSpc>
                 <a:spcPct val="140000"/>
               </a:lnSpc>
@@ -10904,7 +10636,7 @@
             <a:endParaRPr lang="en-US" sz="1400" dirty="0"/>
           </a:p>
           <a:p>
-            <a:pPr indent="0" marL="0">
+            <a:pPr marL="0" indent="0">
               <a:lnSpc>
                 <a:spcPct val="140000"/>
               </a:lnSpc>
@@ -10913,7 +10645,7 @@
             <a:endParaRPr lang="en-US" sz="1400" dirty="0"/>
           </a:p>
           <a:p>
-            <a:pPr indent="0" marL="0">
+            <a:pPr marL="0" indent="0">
               <a:lnSpc>
                 <a:spcPct val="140000"/>
               </a:lnSpc>
@@ -10933,7 +10665,7 @@
             <a:endParaRPr lang="en-US" sz="1400" dirty="0"/>
           </a:p>
           <a:p>
-            <a:pPr indent="0" marL="0">
+            <a:pPr marL="0" indent="0">
               <a:lnSpc>
                 <a:spcPct val="140000"/>
               </a:lnSpc>
@@ -10942,7 +10674,7 @@
             <a:endParaRPr lang="en-US" sz="1400" dirty="0"/>
           </a:p>
           <a:p>
-            <a:pPr indent="0" marL="0">
+            <a:pPr marL="0" indent="0">
               <a:lnSpc>
                 <a:spcPct val="140000"/>
               </a:lnSpc>
@@ -10962,7 +10694,7 @@
             <a:endParaRPr lang="en-US" sz="1400" dirty="0"/>
           </a:p>
           <a:p>
-            <a:pPr indent="0" marL="0">
+            <a:pPr marL="0" indent="0">
               <a:lnSpc>
                 <a:spcPct val="140000"/>
               </a:lnSpc>
@@ -10982,7 +10714,7 @@
             <a:endParaRPr lang="en-US" sz="1400" dirty="0"/>
           </a:p>
           <a:p>
-            <a:pPr indent="0" marL="0">
+            <a:pPr marL="0" indent="0">
               <a:lnSpc>
                 <a:spcPct val="140000"/>
               </a:lnSpc>
@@ -11051,7 +10783,7 @@
           <a:bodyPr wrap="square" rtlCol="0" anchor="ctr"/>
           <a:lstStyle/>
           <a:p>
-            <a:pPr algn="ctr" indent="0" marL="0">
+            <a:pPr marL="0" indent="0" algn="ctr">
               <a:buNone/>
             </a:pPr>
             <a:r>
@@ -11090,7 +10822,7 @@
           <a:bodyPr wrap="square" rtlCol="0" anchor="ctr"/>
           <a:lstStyle/>
           <a:p>
-            <a:pPr algn="ctr" indent="0" marL="0">
+            <a:pPr marL="0" indent="0" algn="ctr">
               <a:buNone/>
             </a:pPr>
             <a:r>
@@ -11129,7 +10861,7 @@
           <a:bodyPr wrap="square" rtlCol="0" anchor="ctr"/>
           <a:lstStyle/>
           <a:p>
-            <a:pPr algn="ctr" indent="0" marL="0">
+            <a:pPr marL="0" indent="0" algn="ctr">
               <a:buNone/>
             </a:pPr>
             <a:r>
@@ -11149,14 +10881,14 @@
       </p:sp>
       <p:pic>
         <p:nvPicPr>
-          <p:cNvPr id="9" name="Image 0" descr="/sessions/sleepy-zen-cray/mnt/outputs/deck_assets/logo_var2_azul.png">    </p:cNvPr>
+          <p:cNvPr id="9" name="Image 0" descr="/sessions/sleepy-zen-cray/mnt/outputs/deck_assets/logo_var2_azul.png"/>
           <p:cNvPicPr>
             <a:picLocks noChangeAspect="1"/>
           </p:cNvPicPr>
           <p:nvPr/>
         </p:nvPicPr>
         <p:blipFill>
-          <a:blip r:embed="rId1"/>
+          <a:blip r:embed="rId3"/>
           <a:stretch>
             <a:fillRect/>
           </a:stretch>
@@ -11173,14 +10905,14 @@
       </p:pic>
       <p:pic>
         <p:nvPicPr>
-          <p:cNvPr id="10" name="Image 1" descr="/sessions/sleepy-zen-cray/mnt/outputs/deck_assets/sello_linea_v1_01.png">    </p:cNvPr>
+          <p:cNvPr id="10" name="Image 1" descr="/sessions/sleepy-zen-cray/mnt/outputs/deck_assets/sello_linea_v1_01.png"/>
           <p:cNvPicPr>
             <a:picLocks noChangeAspect="1"/>
           </p:cNvPicPr>
           <p:nvPr/>
         </p:nvPicPr>
         <p:blipFill>
-          <a:blip r:embed="rId2"/>
+          <a:blip r:embed="rId4"/>
           <a:stretch>
             <a:fillRect/>
           </a:stretch>
@@ -11216,7 +10948,7 @@
           <a:bodyPr wrap="square" rtlCol="0" anchor="ctr"/>
           <a:lstStyle/>
           <a:p>
-            <a:pPr indent="0" marL="0">
+            <a:pPr marL="0" indent="0">
               <a:buNone/>
             </a:pPr>
             <a:r>
@@ -11255,7 +10987,7 @@
           <a:bodyPr wrap="square" rtlCol="0" anchor="ctr"/>
           <a:lstStyle/>
           <a:p>
-            <a:pPr algn="r" indent="0" marL="0">
+            <a:pPr marL="0" indent="0" algn="r">
               <a:buNone/>
             </a:pPr>
             <a:r>
@@ -11289,6 +11021,7 @@
         <a:solidFill>
           <a:srgbClr val="FFFFFF"/>
         </a:solidFill>
+        <a:effectLst/>
       </p:bgPr>
     </p:bg>
     <p:spTree>
@@ -11326,11 +11059,11 @@
           <a:bodyPr wrap="square" rtlCol="0" anchor="ctr"/>
           <a:lstStyle/>
           <a:p>
-            <a:pPr indent="0" marL="0">
-              <a:buNone/>
-            </a:pPr>
-            <a:r>
-              <a:rPr lang="en-US" sz="900" b="1" spc="600" kern="0" dirty="0">
+            <a:pPr marL="0" indent="0">
+              <a:buNone/>
+            </a:pPr>
+            <a:r>
+              <a:rPr lang="en-US" sz="900" b="1" kern="0" spc="600" dirty="0">
                 <a:solidFill>
                   <a:srgbClr val="FF5C5C"/>
                 </a:solidFill>
@@ -11365,7 +11098,7 @@
           <a:bodyPr wrap="square" rtlCol="0" anchor="ctr"/>
           <a:lstStyle/>
           <a:p>
-            <a:pPr indent="0" marL="0">
+            <a:pPr marL="0" indent="0">
               <a:buNone/>
             </a:pPr>
             <a:r>
@@ -11404,7 +11137,7 @@
           <a:bodyPr wrap="square" rtlCol="0" anchor="ctr"/>
           <a:lstStyle/>
           <a:p>
-            <a:pPr indent="0" marL="0">
+            <a:pPr marL="0" indent="0">
               <a:buNone/>
             </a:pPr>
             <a:r>
@@ -11470,7 +11203,7 @@
           <a:bodyPr wrap="square" rtlCol="0" anchor="ctr"/>
           <a:lstStyle/>
           <a:p>
-            <a:pPr algn="ctr" indent="0" marL="0">
+            <a:pPr marL="0" indent="0" algn="ctr">
               <a:buNone/>
             </a:pPr>
             <a:r>
@@ -11509,7 +11242,7 @@
           <a:bodyPr wrap="square" rtlCol="0" anchor="t"/>
           <a:lstStyle/>
           <a:p>
-            <a:pPr algn="ctr" indent="0" marL="0">
+            <a:pPr marL="0" indent="0" algn="ctr">
               <a:buNone/>
             </a:pPr>
             <a:r>
@@ -11575,7 +11308,7 @@
           <a:bodyPr wrap="square" rtlCol="0" anchor="ctr"/>
           <a:lstStyle/>
           <a:p>
-            <a:pPr algn="ctr" indent="0" marL="0">
+            <a:pPr marL="0" indent="0" algn="ctr">
               <a:buNone/>
             </a:pPr>
             <a:r>
@@ -11614,7 +11347,7 @@
           <a:bodyPr wrap="square" rtlCol="0" anchor="t"/>
           <a:lstStyle/>
           <a:p>
-            <a:pPr algn="ctr" indent="0" marL="0">
+            <a:pPr marL="0" indent="0" algn="ctr">
               <a:buNone/>
             </a:pPr>
             <a:r>
@@ -11680,7 +11413,7 @@
           <a:bodyPr wrap="square" rtlCol="0" anchor="ctr"/>
           <a:lstStyle/>
           <a:p>
-            <a:pPr algn="ctr" indent="0" marL="0">
+            <a:pPr marL="0" indent="0" algn="ctr">
               <a:buNone/>
             </a:pPr>
             <a:r>
@@ -11719,7 +11452,7 @@
           <a:bodyPr wrap="square" rtlCol="0" anchor="t"/>
           <a:lstStyle/>
           <a:p>
-            <a:pPr algn="ctr" indent="0" marL="0">
+            <a:pPr marL="0" indent="0" algn="ctr">
               <a:buNone/>
             </a:pPr>
             <a:r>
@@ -11785,7 +11518,7 @@
           <a:bodyPr wrap="square" rtlCol="0" anchor="ctr"/>
           <a:lstStyle/>
           <a:p>
-            <a:pPr algn="ctr" indent="0" marL="0">
+            <a:pPr marL="0" indent="0" algn="ctr">
               <a:buNone/>
             </a:pPr>
             <a:r>
@@ -11824,7 +11557,7 @@
           <a:bodyPr wrap="square" rtlCol="0" anchor="t"/>
           <a:lstStyle/>
           <a:p>
-            <a:pPr algn="ctr" indent="0" marL="0">
+            <a:pPr marL="0" indent="0" algn="ctr">
               <a:buNone/>
             </a:pPr>
             <a:r>
@@ -11890,7 +11623,7 @@
           <a:bodyPr wrap="square" rtlCol="0" anchor="ctr"/>
           <a:lstStyle/>
           <a:p>
-            <a:pPr algn="ctr" indent="0" marL="0">
+            <a:pPr marL="0" indent="0" algn="ctr">
               <a:buNone/>
             </a:pPr>
             <a:r>
@@ -11929,7 +11662,7 @@
           <a:bodyPr wrap="square" rtlCol="0" anchor="t"/>
           <a:lstStyle/>
           <a:p>
-            <a:pPr algn="ctr" indent="0" marL="0">
+            <a:pPr marL="0" indent="0" algn="ctr">
               <a:buNone/>
             </a:pPr>
             <a:r>
@@ -11995,7 +11728,7 @@
           <a:bodyPr wrap="square" rtlCol="0" anchor="ctr"/>
           <a:lstStyle/>
           <a:p>
-            <a:pPr algn="ctr" indent="0" marL="0">
+            <a:pPr marL="0" indent="0" algn="ctr">
               <a:buNone/>
             </a:pPr>
             <a:r>
@@ -12034,7 +11767,7 @@
           <a:bodyPr wrap="square" rtlCol="0" anchor="t"/>
           <a:lstStyle/>
           <a:p>
-            <a:pPr algn="ctr" indent="0" marL="0">
+            <a:pPr marL="0" indent="0" algn="ctr">
               <a:buNone/>
             </a:pPr>
             <a:r>
@@ -12054,14 +11787,14 @@
       </p:sp>
       <p:pic>
         <p:nvPicPr>
-          <p:cNvPr id="23" name="Image 0" descr="/sessions/sleepy-zen-cray/mnt/outputs/deck_assets/logo_var2_azul.png">    </p:cNvPr>
+          <p:cNvPr id="23" name="Image 0" descr="/sessions/sleepy-zen-cray/mnt/outputs/deck_assets/logo_var2_azul.png"/>
           <p:cNvPicPr>
             <a:picLocks noChangeAspect="1"/>
           </p:cNvPicPr>
           <p:nvPr/>
         </p:nvPicPr>
         <p:blipFill>
-          <a:blip r:embed="rId1"/>
+          <a:blip r:embed="rId3"/>
           <a:stretch>
             <a:fillRect/>
           </a:stretch>
@@ -12078,14 +11811,14 @@
       </p:pic>
       <p:pic>
         <p:nvPicPr>
-          <p:cNvPr id="24" name="Image 1" descr="/sessions/sleepy-zen-cray/mnt/outputs/deck_assets/sello_linea_v1_01.png">    </p:cNvPr>
+          <p:cNvPr id="24" name="Image 1" descr="/sessions/sleepy-zen-cray/mnt/outputs/deck_assets/sello_linea_v1_01.png"/>
           <p:cNvPicPr>
             <a:picLocks noChangeAspect="1"/>
           </p:cNvPicPr>
           <p:nvPr/>
         </p:nvPicPr>
         <p:blipFill>
-          <a:blip r:embed="rId2"/>
+          <a:blip r:embed="rId4"/>
           <a:stretch>
             <a:fillRect/>
           </a:stretch>
@@ -12121,7 +11854,7 @@
           <a:bodyPr wrap="square" rtlCol="0" anchor="ctr"/>
           <a:lstStyle/>
           <a:p>
-            <a:pPr indent="0" marL="0">
+            <a:pPr marL="0" indent="0">
               <a:buNone/>
             </a:pPr>
             <a:r>
@@ -12160,7 +11893,7 @@
           <a:bodyPr wrap="square" rtlCol="0" anchor="ctr"/>
           <a:lstStyle/>
           <a:p>
-            <a:pPr algn="r" indent="0" marL="0">
+            <a:pPr marL="0" indent="0" algn="r">
               <a:buNone/>
             </a:pPr>
             <a:r>
@@ -12194,6 +11927,7 @@
         <a:solidFill>
           <a:srgbClr val="FFFFFF"/>
         </a:solidFill>
+        <a:effectLst/>
       </p:bgPr>
     </p:bg>
     <p:spTree>
@@ -12231,11 +11965,11 @@
           <a:bodyPr wrap="square" rtlCol="0" anchor="ctr"/>
           <a:lstStyle/>
           <a:p>
-            <a:pPr indent="0" marL="0">
-              <a:buNone/>
-            </a:pPr>
-            <a:r>
-              <a:rPr lang="en-US" sz="900" b="1" spc="600" kern="0" dirty="0">
+            <a:pPr marL="0" indent="0">
+              <a:buNone/>
+            </a:pPr>
+            <a:r>
+              <a:rPr lang="en-US" sz="900" b="1" kern="0" spc="600" dirty="0">
                 <a:solidFill>
                   <a:srgbClr val="3D2EE8"/>
                 </a:solidFill>
@@ -12270,7 +12004,7 @@
           <a:bodyPr wrap="square" rtlCol="0" anchor="ctr"/>
           <a:lstStyle/>
           <a:p>
-            <a:pPr indent="0" marL="0">
+            <a:pPr marL="0" indent="0">
               <a:buNone/>
             </a:pPr>
             <a:r>
@@ -12309,7 +12043,7 @@
           <a:bodyPr wrap="square" rtlCol="0" anchor="t"/>
           <a:lstStyle/>
           <a:p>
-            <a:pPr indent="0" marL="0">
+            <a:pPr marL="0" indent="0">
               <a:lnSpc>
                 <a:spcPct val="140000"/>
               </a:lnSpc>
@@ -12329,7 +12063,7 @@
             <a:endParaRPr lang="en-US" sz="1400" dirty="0"/>
           </a:p>
           <a:p>
-            <a:pPr indent="0" marL="0">
+            <a:pPr marL="0" indent="0">
               <a:lnSpc>
                 <a:spcPct val="140000"/>
               </a:lnSpc>
@@ -12338,7 +12072,7 @@
             <a:endParaRPr lang="en-US" sz="1400" dirty="0"/>
           </a:p>
           <a:p>
-            <a:pPr indent="0" marL="0">
+            <a:pPr marL="0" indent="0">
               <a:lnSpc>
                 <a:spcPct val="140000"/>
               </a:lnSpc>
@@ -12358,7 +12092,7 @@
             <a:endParaRPr lang="en-US" sz="1400" dirty="0"/>
           </a:p>
           <a:p>
-            <a:pPr indent="0" marL="0">
+            <a:pPr marL="0" indent="0">
               <a:lnSpc>
                 <a:spcPct val="140000"/>
               </a:lnSpc>
@@ -12367,7 +12101,7 @@
             <a:endParaRPr lang="en-US" sz="1400" dirty="0"/>
           </a:p>
           <a:p>
-            <a:pPr indent="0" marL="0">
+            <a:pPr marL="0" indent="0">
               <a:lnSpc>
                 <a:spcPct val="140000"/>
               </a:lnSpc>
@@ -12387,7 +12121,7 @@
             <a:endParaRPr lang="en-US" sz="1400" dirty="0"/>
           </a:p>
           <a:p>
-            <a:pPr indent="0" marL="0">
+            <a:pPr marL="0" indent="0">
               <a:lnSpc>
                 <a:spcPct val="140000"/>
               </a:lnSpc>
@@ -12407,7 +12141,7 @@
             <a:endParaRPr lang="en-US" sz="1400" dirty="0"/>
           </a:p>
           <a:p>
-            <a:pPr indent="0" marL="0">
+            <a:pPr marL="0" indent="0">
               <a:lnSpc>
                 <a:spcPct val="140000"/>
               </a:lnSpc>
@@ -12427,7 +12161,7 @@
             <a:endParaRPr lang="en-US" sz="1400" dirty="0"/>
           </a:p>
           <a:p>
-            <a:pPr indent="0" marL="0">
+            <a:pPr marL="0" indent="0">
               <a:lnSpc>
                 <a:spcPct val="140000"/>
               </a:lnSpc>
@@ -12436,7 +12170,7 @@
             <a:endParaRPr lang="en-US" sz="1400" dirty="0"/>
           </a:p>
           <a:p>
-            <a:pPr indent="0" marL="0">
+            <a:pPr marL="0" indent="0">
               <a:lnSpc>
                 <a:spcPct val="140000"/>
               </a:lnSpc>
@@ -12505,7 +12239,7 @@
           <a:bodyPr wrap="square" rtlCol="0" anchor="ctr"/>
           <a:lstStyle/>
           <a:p>
-            <a:pPr algn="ctr" indent="0" marL="0">
+            <a:pPr marL="0" indent="0" algn="ctr">
               <a:buNone/>
             </a:pPr>
             <a:r>
@@ -12544,7 +12278,7 @@
           <a:bodyPr wrap="square" rtlCol="0" anchor="ctr"/>
           <a:lstStyle/>
           <a:p>
-            <a:pPr algn="ctr" indent="0" marL="0">
+            <a:pPr marL="0" indent="0" algn="ctr">
               <a:buNone/>
             </a:pPr>
             <a:r>
@@ -12583,7 +12317,7 @@
           <a:bodyPr wrap="square" rtlCol="0" anchor="ctr"/>
           <a:lstStyle/>
           <a:p>
-            <a:pPr algn="ctr" indent="0" marL="0">
+            <a:pPr marL="0" indent="0" algn="ctr">
               <a:buNone/>
             </a:pPr>
             <a:r>
@@ -12603,14 +12337,14 @@
       </p:sp>
       <p:pic>
         <p:nvPicPr>
-          <p:cNvPr id="9" name="Image 0" descr="/sessions/sleepy-zen-cray/mnt/outputs/deck_assets/logo_var2_azul.png">    </p:cNvPr>
+          <p:cNvPr id="9" name="Image 0" descr="/sessions/sleepy-zen-cray/mnt/outputs/deck_assets/logo_var2_azul.png"/>
           <p:cNvPicPr>
             <a:picLocks noChangeAspect="1"/>
           </p:cNvPicPr>
           <p:nvPr/>
         </p:nvPicPr>
         <p:blipFill>
-          <a:blip r:embed="rId1"/>
+          <a:blip r:embed="rId3"/>
           <a:stretch>
             <a:fillRect/>
           </a:stretch>
@@ -12627,14 +12361,14 @@
       </p:pic>
       <p:pic>
         <p:nvPicPr>
-          <p:cNvPr id="10" name="Image 1" descr="/sessions/sleepy-zen-cray/mnt/outputs/deck_assets/sello_linea_v1_01.png">    </p:cNvPr>
+          <p:cNvPr id="10" name="Image 1" descr="/sessions/sleepy-zen-cray/mnt/outputs/deck_assets/sello_linea_v1_01.png"/>
           <p:cNvPicPr>
             <a:picLocks noChangeAspect="1"/>
           </p:cNvPicPr>
           <p:nvPr/>
         </p:nvPicPr>
         <p:blipFill>
-          <a:blip r:embed="rId2"/>
+          <a:blip r:embed="rId4"/>
           <a:stretch>
             <a:fillRect/>
           </a:stretch>
@@ -12670,7 +12404,7 @@
           <a:bodyPr wrap="square" rtlCol="0" anchor="ctr"/>
           <a:lstStyle/>
           <a:p>
-            <a:pPr indent="0" marL="0">
+            <a:pPr marL="0" indent="0">
               <a:buNone/>
             </a:pPr>
             <a:r>
@@ -12709,7 +12443,7 @@
           <a:bodyPr wrap="square" rtlCol="0" anchor="ctr"/>
           <a:lstStyle/>
           <a:p>
-            <a:pPr algn="r" indent="0" marL="0">
+            <a:pPr marL="0" indent="0" algn="r">
               <a:buNone/>
             </a:pPr>
             <a:r>
@@ -12743,6 +12477,7 @@
         <a:solidFill>
           <a:srgbClr val="FFFFFF"/>
         </a:solidFill>
+        <a:effectLst/>
       </p:bgPr>
     </p:bg>
     <p:spTree>
@@ -12780,11 +12515,11 @@
           <a:bodyPr wrap="square" rtlCol="0" anchor="ctr"/>
           <a:lstStyle/>
           <a:p>
-            <a:pPr indent="0" marL="0">
-              <a:buNone/>
-            </a:pPr>
-            <a:r>
-              <a:rPr lang="en-US" sz="900" b="1" spc="600" kern="0" dirty="0">
+            <a:pPr marL="0" indent="0">
+              <a:buNone/>
+            </a:pPr>
+            <a:r>
+              <a:rPr lang="en-US" sz="900" b="1" kern="0" spc="600" dirty="0">
                 <a:solidFill>
                   <a:srgbClr val="3D2EE8"/>
                 </a:solidFill>
@@ -12819,7 +12554,7 @@
           <a:bodyPr wrap="square" rtlCol="0" anchor="ctr"/>
           <a:lstStyle/>
           <a:p>
-            <a:pPr indent="0" marL="0">
+            <a:pPr marL="0" indent="0">
               <a:buNone/>
             </a:pPr>
             <a:r>
@@ -12885,7 +12620,7 @@
           <a:bodyPr wrap="square" rtlCol="0" anchor="ctr"/>
           <a:lstStyle/>
           <a:p>
-            <a:pPr indent="0" marL="0">
+            <a:pPr marL="0" indent="0">
               <a:buNone/>
             </a:pPr>
             <a:r>
@@ -12924,11 +12659,11 @@
           <a:bodyPr wrap="square" rtlCol="0" anchor="ctr"/>
           <a:lstStyle/>
           <a:p>
-            <a:pPr indent="0" marL="0">
-              <a:buNone/>
-            </a:pPr>
-            <a:r>
-              <a:rPr lang="en-US" sz="1200" b="1" spc="400" kern="0" dirty="0">
+            <a:pPr marL="0" indent="0">
+              <a:buNone/>
+            </a:pPr>
+            <a:r>
+              <a:rPr lang="en-US" sz="1200" b="1" kern="0" spc="400" dirty="0">
                 <a:solidFill>
                   <a:srgbClr val="3D2EE8"/>
                 </a:solidFill>
@@ -12963,7 +12698,7 @@
           <a:bodyPr wrap="square" rtlCol="0" anchor="t"/>
           <a:lstStyle/>
           <a:p>
-            <a:pPr indent="0" marL="0">
+            <a:pPr marL="0" indent="0">
               <a:lnSpc>
                 <a:spcPct val="130000"/>
               </a:lnSpc>
@@ -12983,7 +12718,7 @@
             <a:endParaRPr lang="en-US" sz="1800" dirty="0"/>
           </a:p>
           <a:p>
-            <a:pPr indent="0" marL="0">
+            <a:pPr marL="0" indent="0">
               <a:lnSpc>
                 <a:spcPct val="130000"/>
               </a:lnSpc>
@@ -12992,7 +12727,7 @@
             <a:endParaRPr lang="en-US" sz="1800" dirty="0"/>
           </a:p>
           <a:p>
-            <a:pPr indent="0" marL="0">
+            <a:pPr marL="0" indent="0">
               <a:lnSpc>
                 <a:spcPct val="130000"/>
               </a:lnSpc>
@@ -13012,7 +12747,7 @@
             <a:endParaRPr lang="en-US" sz="1800" dirty="0"/>
           </a:p>
           <a:p>
-            <a:pPr indent="0" marL="0">
+            <a:pPr marL="0" indent="0">
               <a:lnSpc>
                 <a:spcPct val="130000"/>
               </a:lnSpc>
@@ -13021,7 +12756,7 @@
             <a:endParaRPr lang="en-US" sz="1800" dirty="0"/>
           </a:p>
           <a:p>
-            <a:pPr indent="0" marL="0">
+            <a:pPr marL="0" indent="0">
               <a:lnSpc>
                 <a:spcPct val="130000"/>
               </a:lnSpc>
@@ -13041,7 +12776,7 @@
             <a:endParaRPr lang="en-US" sz="1800" dirty="0"/>
           </a:p>
           <a:p>
-            <a:pPr indent="0" marL="0">
+            <a:pPr marL="0" indent="0">
               <a:lnSpc>
                 <a:spcPct val="130000"/>
               </a:lnSpc>
@@ -13050,7 +12785,7 @@
             <a:endParaRPr lang="en-US" sz="1800" dirty="0"/>
           </a:p>
           <a:p>
-            <a:pPr indent="0" marL="0">
+            <a:pPr marL="0" indent="0">
               <a:lnSpc>
                 <a:spcPct val="130000"/>
               </a:lnSpc>
@@ -13070,7 +12805,7 @@
             <a:endParaRPr lang="en-US" sz="1800" dirty="0"/>
           </a:p>
           <a:p>
-            <a:pPr indent="0" marL="0">
+            <a:pPr marL="0" indent="0">
               <a:lnSpc>
                 <a:spcPct val="130000"/>
               </a:lnSpc>
@@ -13079,7 +12814,7 @@
             <a:endParaRPr lang="en-US" sz="1800" dirty="0"/>
           </a:p>
           <a:p>
-            <a:pPr indent="0" marL="0">
+            <a:pPr marL="0" indent="0">
               <a:lnSpc>
                 <a:spcPct val="130000"/>
               </a:lnSpc>
@@ -13102,14 +12837,14 @@
       </p:sp>
       <p:pic>
         <p:nvPicPr>
-          <p:cNvPr id="8" name="Image 0" descr="/sessions/sleepy-zen-cray/mnt/outputs/deck_assets/flor_01.png">    </p:cNvPr>
+          <p:cNvPr id="8" name="Image 0" descr="/sessions/sleepy-zen-cray/mnt/outputs/deck_assets/flor_01.png"/>
           <p:cNvPicPr>
             <a:picLocks noChangeAspect="1"/>
           </p:cNvPicPr>
           <p:nvPr/>
         </p:nvPicPr>
         <p:blipFill>
-          <a:blip r:embed="rId1">
+          <a:blip r:embed="rId3">
             <a:alphaModFix amt="30000"/>
           </a:blip>
           <a:stretch>
@@ -13128,14 +12863,14 @@
       </p:pic>
       <p:pic>
         <p:nvPicPr>
-          <p:cNvPr id="9" name="Image 1" descr="/sessions/sleepy-zen-cray/mnt/outputs/deck_assets/logo_var2_azul.png">    </p:cNvPr>
+          <p:cNvPr id="9" name="Image 1" descr="/sessions/sleepy-zen-cray/mnt/outputs/deck_assets/logo_var2_azul.png"/>
           <p:cNvPicPr>
             <a:picLocks noChangeAspect="1"/>
           </p:cNvPicPr>
           <p:nvPr/>
         </p:nvPicPr>
         <p:blipFill>
-          <a:blip r:embed="rId2"/>
+          <a:blip r:embed="rId4"/>
           <a:stretch>
             <a:fillRect/>
           </a:stretch>
@@ -13152,14 +12887,14 @@
       </p:pic>
       <p:pic>
         <p:nvPicPr>
-          <p:cNvPr id="10" name="Image 2" descr="/sessions/sleepy-zen-cray/mnt/outputs/deck_assets/sello_linea_v1_01.png">    </p:cNvPr>
+          <p:cNvPr id="10" name="Image 2" descr="/sessions/sleepy-zen-cray/mnt/outputs/deck_assets/sello_linea_v1_01.png"/>
           <p:cNvPicPr>
             <a:picLocks noChangeAspect="1"/>
           </p:cNvPicPr>
           <p:nvPr/>
         </p:nvPicPr>
         <p:blipFill>
-          <a:blip r:embed="rId3"/>
+          <a:blip r:embed="rId5"/>
           <a:stretch>
             <a:fillRect/>
           </a:stretch>
@@ -13195,7 +12930,7 @@
           <a:bodyPr wrap="square" rtlCol="0" anchor="ctr"/>
           <a:lstStyle/>
           <a:p>
-            <a:pPr indent="0" marL="0">
+            <a:pPr marL="0" indent="0">
               <a:buNone/>
             </a:pPr>
             <a:r>
@@ -13234,7 +12969,7 @@
           <a:bodyPr wrap="square" rtlCol="0" anchor="ctr"/>
           <a:lstStyle/>
           <a:p>
-            <a:pPr algn="r" indent="0" marL="0">
+            <a:pPr marL="0" indent="0" algn="r">
               <a:buNone/>
             </a:pPr>
             <a:r>
@@ -13553,4 +13288,299 @@
     </a:ext>
   </a:extLst>
 </a:theme>
+</file>
+
+<file path=ppt/theme/theme2.xml><?xml version="1.0" encoding="utf-8"?>
+<a:theme xmlns:a="http://schemas.openxmlformats.org/drawingml/2006/main" name="Office Theme">
+  <a:themeElements>
+    <a:clrScheme name="Office">
+      <a:dk1>
+        <a:sysClr val="windowText" lastClr="000000"/>
+      </a:dk1>
+      <a:lt1>
+        <a:sysClr val="window" lastClr="FFFFFF"/>
+      </a:lt1>
+      <a:dk2>
+        <a:srgbClr val="44546A"/>
+      </a:dk2>
+      <a:lt2>
+        <a:srgbClr val="E7E6E6"/>
+      </a:lt2>
+      <a:accent1>
+        <a:srgbClr val="4472C4"/>
+      </a:accent1>
+      <a:accent2>
+        <a:srgbClr val="ED7D31"/>
+      </a:accent2>
+      <a:accent3>
+        <a:srgbClr val="A5A5A5"/>
+      </a:accent3>
+      <a:accent4>
+        <a:srgbClr val="FFC000"/>
+      </a:accent4>
+      <a:accent5>
+        <a:srgbClr val="5B9BD5"/>
+      </a:accent5>
+      <a:accent6>
+        <a:srgbClr val="70AD47"/>
+      </a:accent6>
+      <a:hlink>
+        <a:srgbClr val="0563C1"/>
+      </a:hlink>
+      <a:folHlink>
+        <a:srgbClr val="954F72"/>
+      </a:folHlink>
+    </a:clrScheme>
+    <a:fontScheme name="Office">
+      <a:majorFont>
+        <a:latin typeface="Calibri Light" panose="020F0302020204030204"/>
+        <a:ea typeface=""/>
+        <a:cs typeface=""/>
+        <a:font script="Jpan" typeface="游ゴシック Light"/>
+        <a:font script="Hang" typeface="맑은 고딕"/>
+        <a:font script="Hans" typeface="等线 Light"/>
+        <a:font script="Hant" typeface="新細明體"/>
+        <a:font script="Arab" typeface="Times New Roman"/>
+        <a:font script="Hebr" typeface="Times New Roman"/>
+        <a:font script="Thai" typeface="Angsana New"/>
+        <a:font script="Ethi" typeface="Nyala"/>
+        <a:font script="Beng" typeface="Vrinda"/>
+        <a:font script="Gujr" typeface="Shruti"/>
+        <a:font script="Khmr" typeface="MoolBoran"/>
+        <a:font script="Knda" typeface="Tunga"/>
+        <a:font script="Guru" typeface="Raavi"/>
+        <a:font script="Cans" typeface="Euphemia"/>
+        <a:font script="Cher" typeface="Plantagenet Cherokee"/>
+        <a:font script="Yiii" typeface="Microsoft Yi Baiti"/>
+        <a:font script="Tibt" typeface="Microsoft Himalaya"/>
+        <a:font script="Thaa" typeface="MV Boli"/>
+        <a:font script="Deva" typeface="Mangal"/>
+        <a:font script="Telu" typeface="Gautami"/>
+        <a:font script="Taml" typeface="Latha"/>
+        <a:font script="Syrc" typeface="Estrangelo Edessa"/>
+        <a:font script="Orya" typeface="Kalinga"/>
+        <a:font script="Mlym" typeface="Kartika"/>
+        <a:font script="Laoo" typeface="DokChampa"/>
+        <a:font script="Sinh" typeface="Iskoola Pota"/>
+        <a:font script="Mong" typeface="Mongolian Baiti"/>
+        <a:font script="Viet" typeface="Times New Roman"/>
+        <a:font script="Uigh" typeface="Microsoft Uighur"/>
+        <a:font script="Geor" typeface="Sylfaen"/>
+        <a:font script="Armn" typeface="Arial"/>
+        <a:font script="Bugi" typeface="Leelawadee UI"/>
+        <a:font script="Bopo" typeface="Microsoft JhengHei"/>
+        <a:font script="Java" typeface="Javanese Text"/>
+        <a:font script="Lisu" typeface="Segoe UI"/>
+        <a:font script="Mymr" typeface="Myanmar Text"/>
+        <a:font script="Nkoo" typeface="Ebrima"/>
+        <a:font script="Olck" typeface="Nirmala UI"/>
+        <a:font script="Osma" typeface="Ebrima"/>
+        <a:font script="Phag" typeface="Phagspa"/>
+        <a:font script="Syrn" typeface="Estrangelo Edessa"/>
+        <a:font script="Syrj" typeface="Estrangelo Edessa"/>
+        <a:font script="Syre" typeface="Estrangelo Edessa"/>
+        <a:font script="Sora" typeface="Nirmala UI"/>
+        <a:font script="Tale" typeface="Microsoft Tai Le"/>
+        <a:font script="Talu" typeface="Microsoft New Tai Lue"/>
+        <a:font script="Tfng" typeface="Ebrima"/>
+      </a:majorFont>
+      <a:minorFont>
+        <a:latin typeface="Calibri" panose="020F0502020204030204"/>
+        <a:ea typeface=""/>
+        <a:cs typeface=""/>
+        <a:font script="Jpan" typeface="游ゴシック"/>
+        <a:font script="Hang" typeface="맑은 고딕"/>
+        <a:font script="Hans" typeface="等线"/>
+        <a:font script="Hant" typeface="新細明體"/>
+        <a:font script="Arab" typeface="Arial"/>
+        <a:font script="Hebr" typeface="Arial"/>
+        <a:font script="Thai" typeface="Cordia New"/>
+        <a:font script="Ethi" typeface="Nyala"/>
+        <a:font script="Beng" typeface="Vrinda"/>
+        <a:font script="Gujr" typeface="Shruti"/>
+        <a:font script="Khmr" typeface="DaunPenh"/>
+        <a:font script="Knda" typeface="Tunga"/>
+        <a:font script="Guru" typeface="Raavi"/>
+        <a:font script="Cans" typeface="Euphemia"/>
+        <a:font script="Cher" typeface="Plantagenet Cherokee"/>
+        <a:font script="Yiii" typeface="Microsoft Yi Baiti"/>
+        <a:font script="Tibt" typeface="Microsoft Himalaya"/>
+        <a:font script="Thaa" typeface="MV Boli"/>
+        <a:font script="Deva" typeface="Mangal"/>
+        <a:font script="Telu" typeface="Gautami"/>
+        <a:font script="Taml" typeface="Latha"/>
+        <a:font script="Syrc" typeface="Estrangelo Edessa"/>
+        <a:font script="Orya" typeface="Kalinga"/>
+        <a:font script="Mlym" typeface="Kartika"/>
+        <a:font script="Laoo" typeface="DokChampa"/>
+        <a:font script="Sinh" typeface="Iskoola Pota"/>
+        <a:font script="Mong" typeface="Mongolian Baiti"/>
+        <a:font script="Viet" typeface="Arial"/>
+        <a:font script="Uigh" typeface="Microsoft Uighur"/>
+        <a:font script="Geor" typeface="Sylfaen"/>
+        <a:font script="Armn" typeface="Arial"/>
+        <a:font script="Bugi" typeface="Leelawadee UI"/>
+        <a:font script="Bopo" typeface="Microsoft JhengHei"/>
+        <a:font script="Java" typeface="Javanese Text"/>
+        <a:font script="Lisu" typeface="Segoe UI"/>
+        <a:font script="Mymr" typeface="Myanmar Text"/>
+        <a:font script="Nkoo" typeface="Ebrima"/>
+        <a:font script="Olck" typeface="Nirmala UI"/>
+        <a:font script="Osma" typeface="Ebrima"/>
+        <a:font script="Phag" typeface="Phagspa"/>
+        <a:font script="Syrn" typeface="Estrangelo Edessa"/>
+        <a:font script="Syrj" typeface="Estrangelo Edessa"/>
+        <a:font script="Syre" typeface="Estrangelo Edessa"/>
+        <a:font script="Sora" typeface="Nirmala UI"/>
+        <a:font script="Tale" typeface="Microsoft Tai Le"/>
+        <a:font script="Talu" typeface="Microsoft New Tai Lue"/>
+        <a:font script="Tfng" typeface="Ebrima"/>
+      </a:minorFont>
+    </a:fontScheme>
+    <a:fmtScheme name="Office">
+      <a:fillStyleLst>
+        <a:solidFill>
+          <a:schemeClr val="phClr"/>
+        </a:solidFill>
+        <a:gradFill rotWithShape="1">
+          <a:gsLst>
+            <a:gs pos="0">
+              <a:schemeClr val="phClr">
+                <a:lumMod val="110000"/>
+                <a:satMod val="105000"/>
+                <a:tint val="67000"/>
+              </a:schemeClr>
+            </a:gs>
+            <a:gs pos="50000">
+              <a:schemeClr val="phClr">
+                <a:lumMod val="105000"/>
+                <a:satMod val="103000"/>
+                <a:tint val="73000"/>
+              </a:schemeClr>
+            </a:gs>
+            <a:gs pos="100000">
+              <a:schemeClr val="phClr">
+                <a:lumMod val="105000"/>
+                <a:satMod val="109000"/>
+                <a:tint val="81000"/>
+              </a:schemeClr>
+            </a:gs>
+          </a:gsLst>
+          <a:lin ang="5400000" scaled="0"/>
+        </a:gradFill>
+        <a:gradFill rotWithShape="1">
+          <a:gsLst>
+            <a:gs pos="0">
+              <a:schemeClr val="phClr">
+                <a:satMod val="103000"/>
+                <a:lumMod val="102000"/>
+                <a:tint val="94000"/>
+              </a:schemeClr>
+            </a:gs>
+            <a:gs pos="50000">
+              <a:schemeClr val="phClr">
+                <a:satMod val="110000"/>
+                <a:lumMod val="100000"/>
+                <a:shade val="100000"/>
+              </a:schemeClr>
+            </a:gs>
+            <a:gs pos="100000">
+              <a:schemeClr val="phClr">
+                <a:lumMod val="99000"/>
+                <a:satMod val="120000"/>
+                <a:shade val="78000"/>
+              </a:schemeClr>
+            </a:gs>
+          </a:gsLst>
+          <a:lin ang="5400000" scaled="0"/>
+        </a:gradFill>
+      </a:fillStyleLst>
+      <a:lnStyleLst>
+        <a:ln w="6350" cap="flat" cmpd="sng" algn="ctr">
+          <a:solidFill>
+            <a:schemeClr val="phClr"/>
+          </a:solidFill>
+          <a:prstDash val="solid"/>
+          <a:miter lim="800000"/>
+        </a:ln>
+        <a:ln w="12700" cap="flat" cmpd="sng" algn="ctr">
+          <a:solidFill>
+            <a:schemeClr val="phClr"/>
+          </a:solidFill>
+          <a:prstDash val="solid"/>
+          <a:miter lim="800000"/>
+        </a:ln>
+        <a:ln w="19050" cap="flat" cmpd="sng" algn="ctr">
+          <a:solidFill>
+            <a:schemeClr val="phClr"/>
+          </a:solidFill>
+          <a:prstDash val="solid"/>
+          <a:miter lim="800000"/>
+        </a:ln>
+      </a:lnStyleLst>
+      <a:effectStyleLst>
+        <a:effectStyle>
+          <a:effectLst/>
+        </a:effectStyle>
+        <a:effectStyle>
+          <a:effectLst/>
+        </a:effectStyle>
+        <a:effectStyle>
+          <a:effectLst>
+            <a:outerShdw blurRad="57150" dist="19050" dir="5400000" algn="ctr" rotWithShape="0">
+              <a:srgbClr val="000000">
+                <a:alpha val="63000"/>
+              </a:srgbClr>
+            </a:outerShdw>
+          </a:effectLst>
+        </a:effectStyle>
+      </a:effectStyleLst>
+      <a:bgFillStyleLst>
+        <a:solidFill>
+          <a:schemeClr val="phClr"/>
+        </a:solidFill>
+        <a:solidFill>
+          <a:schemeClr val="phClr">
+            <a:tint val="95000"/>
+            <a:satMod val="170000"/>
+          </a:schemeClr>
+        </a:solidFill>
+        <a:gradFill rotWithShape="1">
+          <a:gsLst>
+            <a:gs pos="0">
+              <a:schemeClr val="phClr">
+                <a:tint val="93000"/>
+                <a:satMod val="150000"/>
+                <a:shade val="98000"/>
+                <a:lumMod val="102000"/>
+              </a:schemeClr>
+            </a:gs>
+            <a:gs pos="50000">
+              <a:schemeClr val="phClr">
+                <a:tint val="98000"/>
+                <a:satMod val="130000"/>
+                <a:shade val="90000"/>
+                <a:lumMod val="103000"/>
+              </a:schemeClr>
+            </a:gs>
+            <a:gs pos="100000">
+              <a:schemeClr val="phClr">
+                <a:shade val="63000"/>
+                <a:satMod val="120000"/>
+              </a:schemeClr>
+            </a:gs>
+          </a:gsLst>
+          <a:lin ang="5400000" scaled="0"/>
+        </a:gradFill>
+      </a:bgFillStyleLst>
+    </a:fmtScheme>
+  </a:themeElements>
+  <a:objectDefaults/>
+  <a:extraClrSchemeLst/>
+  <a:extLst>
+    <a:ext uri="{05A4C25C-085E-4340-85A3-A5531E510DB2}">
+      <thm15:themeFamily xmlns:thm15="http://schemas.microsoft.com/office/thememl/2012/main" name="Office Theme" id="{62F939B6-93AF-4DB8-9C6B-D6C7DFDC589F}" vid="{4A3C46E8-61CC-4603-A589-7422A47A8E4A}"/>
+    </a:ext>
+  </a:extLst>
+</a:theme>
 </file>
</xml_diff>